<commit_message>
Contenuto pronto per Human Review - QA
</commit_message>
<xml_diff>
--- a/MOD-01/MOD-01_slide.pptx
+++ b/MOD-01/MOD-01_slide.pptx
@@ -5,27 +5,27 @@
     <p:sldMasterId id="2147483648" r:id="rId1"/>
   </p:sldMasterIdLst>
   <p:sldIdLst>
-    <p:sldId id="256" r:id="rId7"/>
-    <p:sldId id="257" r:id="rId8"/>
-    <p:sldId id="258" r:id="rId9"/>
-    <p:sldId id="259" r:id="rId10"/>
-    <p:sldId id="260" r:id="rId11"/>
-    <p:sldId id="261" r:id="rId12"/>
-    <p:sldId id="262" r:id="rId13"/>
-    <p:sldId id="263" r:id="rId14"/>
-    <p:sldId id="264" r:id="rId15"/>
-    <p:sldId id="265" r:id="rId16"/>
-    <p:sldId id="266" r:id="rId17"/>
-    <p:sldId id="267" r:id="rId18"/>
-    <p:sldId id="268" r:id="rId19"/>
-    <p:sldId id="269" r:id="rId20"/>
-    <p:sldId id="270" r:id="rId21"/>
-    <p:sldId id="271" r:id="rId22"/>
-    <p:sldId id="272" r:id="rId23"/>
-    <p:sldId id="273" r:id="rId24"/>
-    <p:sldId id="274" r:id="rId25"/>
+    <p:sldId id="256" r:id="rId2"/>
+    <p:sldId id="257" r:id="rId3"/>
+    <p:sldId id="258" r:id="rId4"/>
+    <p:sldId id="259" r:id="rId5"/>
+    <p:sldId id="260" r:id="rId6"/>
+    <p:sldId id="261" r:id="rId7"/>
+    <p:sldId id="262" r:id="rId8"/>
+    <p:sldId id="263" r:id="rId9"/>
+    <p:sldId id="264" r:id="rId10"/>
+    <p:sldId id="265" r:id="rId11"/>
+    <p:sldId id="266" r:id="rId12"/>
+    <p:sldId id="267" r:id="rId13"/>
+    <p:sldId id="268" r:id="rId14"/>
+    <p:sldId id="269" r:id="rId15"/>
+    <p:sldId id="270" r:id="rId16"/>
+    <p:sldId id="271" r:id="rId17"/>
+    <p:sldId id="272" r:id="rId18"/>
+    <p:sldId id="273" r:id="rId19"/>
+    <p:sldId id="274" r:id="rId20"/>
   </p:sldIdLst>
-  <p:sldSz cx="12193200" cy="6858000" type="screen4x3"/>
+  <p:sldSz cx="12193588" cy="6858000"/>
   <p:notesSz cx="6858000" cy="9144000"/>
   <p:defaultTextStyle>
     <a:defPPr>
@@ -122,6 +122,22 @@
       </a:defRPr>
     </a:lvl9pPr>
   </p:defaultTextStyle>
+  <p:extLst>
+    <p:ext uri="{EFAFB233-063F-42B5-8137-9DF3F51BA10A}">
+      <p15:sldGuideLst xmlns:p15="http://schemas.microsoft.com/office/powerpoint/2012/main">
+        <p15:guide id="1" orient="horz" pos="2160">
+          <p15:clr>
+            <a:srgbClr val="A4A3A4"/>
+          </p15:clr>
+        </p15:guide>
+        <p15:guide id="2" pos="2880">
+          <p15:clr>
+            <a:srgbClr val="A4A3A4"/>
+          </p15:clr>
+        </p15:guide>
+      </p15:sldGuideLst>
+    </p:ext>
+  </p:extLst>
 </p:presentation>
 </file>
 
@@ -163,10 +179,9 @@
           <a:lstStyle/>
           <a:p>
             <a:r>
-              <a:rPr lang="en-US" smtClean="0"/>
+              <a:rPr lang="en-US"/>
               <a:t>Click to edit Master title style</a:t>
             </a:r>
-            <a:endParaRPr lang="en-US"/>
           </a:p>
         </p:txBody>
       </p:sp>
@@ -282,10 +297,9 @@
           </a:lstStyle>
           <a:p>
             <a:r>
-              <a:rPr lang="en-US" smtClean="0"/>
+              <a:rPr lang="en-US"/>
               <a:t>Click to edit Master subtitle style</a:t>
             </a:r>
-            <a:endParaRPr lang="en-US"/>
           </a:p>
         </p:txBody>
       </p:sp>
@@ -306,7 +320,7 @@
           <a:p>
             <a:fld id="{5BCAD085-E8A6-8845-BD4E-CB4CCA059FC4}" type="datetimeFigureOut">
               <a:rPr lang="en-US" smtClean="0"/>
-              <a:t>1/27/13</a:t>
+              <a:t>5/18/2026</a:t>
             </a:fld>
             <a:endParaRPr lang="en-US"/>
           </a:p>
@@ -400,10 +414,9 @@
           <a:lstStyle/>
           <a:p>
             <a:r>
-              <a:rPr lang="en-US" smtClean="0"/>
+              <a:rPr lang="en-US"/>
               <a:t>Click to edit Master title style</a:t>
             </a:r>
-            <a:endParaRPr lang="en-US"/>
           </a:p>
         </p:txBody>
       </p:sp>
@@ -424,38 +437,37 @@
           <a:p>
             <a:pPr lvl="0"/>
             <a:r>
-              <a:rPr lang="en-US" smtClean="0"/>
+              <a:rPr lang="en-US"/>
               <a:t>Click to edit Master text styles</a:t>
             </a:r>
           </a:p>
           <a:p>
             <a:pPr lvl="1"/>
             <a:r>
-              <a:rPr lang="en-US" smtClean="0"/>
+              <a:rPr lang="en-US"/>
               <a:t>Second level</a:t>
             </a:r>
           </a:p>
           <a:p>
             <a:pPr lvl="2"/>
             <a:r>
-              <a:rPr lang="en-US" smtClean="0"/>
+              <a:rPr lang="en-US"/>
               <a:t>Third level</a:t>
             </a:r>
           </a:p>
           <a:p>
             <a:pPr lvl="3"/>
             <a:r>
-              <a:rPr lang="en-US" smtClean="0"/>
+              <a:rPr lang="en-US"/>
               <a:t>Fourth level</a:t>
             </a:r>
           </a:p>
           <a:p>
             <a:pPr lvl="4"/>
             <a:r>
-              <a:rPr lang="en-US" smtClean="0"/>
+              <a:rPr lang="en-US"/>
               <a:t>Fifth level</a:t>
             </a:r>
-            <a:endParaRPr lang="en-US"/>
           </a:p>
         </p:txBody>
       </p:sp>
@@ -476,7 +488,7 @@
           <a:p>
             <a:fld id="{5BCAD085-E8A6-8845-BD4E-CB4CCA059FC4}" type="datetimeFigureOut">
               <a:rPr lang="en-US" smtClean="0"/>
-              <a:t>1/27/13</a:t>
+              <a:t>5/18/2026</a:t>
             </a:fld>
             <a:endParaRPr lang="en-US"/>
           </a:p>
@@ -575,10 +587,9 @@
           <a:lstStyle/>
           <a:p>
             <a:r>
-              <a:rPr lang="en-US" smtClean="0"/>
+              <a:rPr lang="en-US"/>
               <a:t>Click to edit Master title style</a:t>
             </a:r>
-            <a:endParaRPr lang="en-US"/>
           </a:p>
         </p:txBody>
       </p:sp>
@@ -604,38 +615,37 @@
           <a:p>
             <a:pPr lvl="0"/>
             <a:r>
-              <a:rPr lang="en-US" smtClean="0"/>
+              <a:rPr lang="en-US"/>
               <a:t>Click to edit Master text styles</a:t>
             </a:r>
           </a:p>
           <a:p>
             <a:pPr lvl="1"/>
             <a:r>
-              <a:rPr lang="en-US" smtClean="0"/>
+              <a:rPr lang="en-US"/>
               <a:t>Second level</a:t>
             </a:r>
           </a:p>
           <a:p>
             <a:pPr lvl="2"/>
             <a:r>
-              <a:rPr lang="en-US" smtClean="0"/>
+              <a:rPr lang="en-US"/>
               <a:t>Third level</a:t>
             </a:r>
           </a:p>
           <a:p>
             <a:pPr lvl="3"/>
             <a:r>
-              <a:rPr lang="en-US" smtClean="0"/>
+              <a:rPr lang="en-US"/>
               <a:t>Fourth level</a:t>
             </a:r>
           </a:p>
           <a:p>
             <a:pPr lvl="4"/>
             <a:r>
-              <a:rPr lang="en-US" smtClean="0"/>
+              <a:rPr lang="en-US"/>
               <a:t>Fifth level</a:t>
             </a:r>
-            <a:endParaRPr lang="en-US"/>
           </a:p>
         </p:txBody>
       </p:sp>
@@ -656,7 +666,7 @@
           <a:p>
             <a:fld id="{5BCAD085-E8A6-8845-BD4E-CB4CCA059FC4}" type="datetimeFigureOut">
               <a:rPr lang="en-US" smtClean="0"/>
-              <a:t>1/27/13</a:t>
+              <a:t>5/18/2026</a:t>
             </a:fld>
             <a:endParaRPr lang="en-US"/>
           </a:p>
@@ -750,10 +760,9 @@
           <a:lstStyle/>
           <a:p>
             <a:r>
-              <a:rPr lang="en-US" smtClean="0"/>
+              <a:rPr lang="en-US"/>
               <a:t>Click to edit Master title style</a:t>
             </a:r>
-            <a:endParaRPr lang="en-US"/>
           </a:p>
         </p:txBody>
       </p:sp>
@@ -774,38 +783,37 @@
           <a:p>
             <a:pPr lvl="0"/>
             <a:r>
-              <a:rPr lang="en-US" smtClean="0"/>
+              <a:rPr lang="en-US"/>
               <a:t>Click to edit Master text styles</a:t>
             </a:r>
           </a:p>
           <a:p>
             <a:pPr lvl="1"/>
             <a:r>
-              <a:rPr lang="en-US" smtClean="0"/>
+              <a:rPr lang="en-US"/>
               <a:t>Second level</a:t>
             </a:r>
           </a:p>
           <a:p>
             <a:pPr lvl="2"/>
             <a:r>
-              <a:rPr lang="en-US" smtClean="0"/>
+              <a:rPr lang="en-US"/>
               <a:t>Third level</a:t>
             </a:r>
           </a:p>
           <a:p>
             <a:pPr lvl="3"/>
             <a:r>
-              <a:rPr lang="en-US" smtClean="0"/>
+              <a:rPr lang="en-US"/>
               <a:t>Fourth level</a:t>
             </a:r>
           </a:p>
           <a:p>
             <a:pPr lvl="4"/>
             <a:r>
-              <a:rPr lang="en-US" smtClean="0"/>
+              <a:rPr lang="en-US"/>
               <a:t>Fifth level</a:t>
             </a:r>
-            <a:endParaRPr lang="en-US"/>
           </a:p>
         </p:txBody>
       </p:sp>
@@ -826,7 +834,7 @@
           <a:p>
             <a:fld id="{5BCAD085-E8A6-8845-BD4E-CB4CCA059FC4}" type="datetimeFigureOut">
               <a:rPr lang="en-US" smtClean="0"/>
-              <a:t>1/27/13</a:t>
+              <a:t>5/18/2026</a:t>
             </a:fld>
             <a:endParaRPr lang="en-US"/>
           </a:p>
@@ -929,10 +937,9 @@
           </a:lstStyle>
           <a:p>
             <a:r>
-              <a:rPr lang="en-US" smtClean="0"/>
+              <a:rPr lang="en-US"/>
               <a:t>Click to edit Master title style</a:t>
             </a:r>
-            <a:endParaRPr lang="en-US"/>
           </a:p>
         </p:txBody>
       </p:sp>
@@ -1049,7 +1056,7 @@
           <a:p>
             <a:pPr lvl="0"/>
             <a:r>
-              <a:rPr lang="en-US" smtClean="0"/>
+              <a:rPr lang="en-US"/>
               <a:t>Click to edit Master text styles</a:t>
             </a:r>
           </a:p>
@@ -1072,7 +1079,7 @@
           <a:p>
             <a:fld id="{5BCAD085-E8A6-8845-BD4E-CB4CCA059FC4}" type="datetimeFigureOut">
               <a:rPr lang="en-US" smtClean="0"/>
-              <a:t>1/27/13</a:t>
+              <a:t>5/18/2026</a:t>
             </a:fld>
             <a:endParaRPr lang="en-US"/>
           </a:p>
@@ -1166,10 +1173,9 @@
           <a:lstStyle/>
           <a:p>
             <a:r>
-              <a:rPr lang="en-US" smtClean="0"/>
+              <a:rPr lang="en-US"/>
               <a:t>Click to edit Master title style</a:t>
             </a:r>
-            <a:endParaRPr lang="en-US"/>
           </a:p>
         </p:txBody>
       </p:sp>
@@ -1223,38 +1229,37 @@
           <a:p>
             <a:pPr lvl="0"/>
             <a:r>
-              <a:rPr lang="en-US" smtClean="0"/>
+              <a:rPr lang="en-US"/>
               <a:t>Click to edit Master text styles</a:t>
             </a:r>
           </a:p>
           <a:p>
             <a:pPr lvl="1"/>
             <a:r>
-              <a:rPr lang="en-US" smtClean="0"/>
+              <a:rPr lang="en-US"/>
               <a:t>Second level</a:t>
             </a:r>
           </a:p>
           <a:p>
             <a:pPr lvl="2"/>
             <a:r>
-              <a:rPr lang="en-US" smtClean="0"/>
+              <a:rPr lang="en-US"/>
               <a:t>Third level</a:t>
             </a:r>
           </a:p>
           <a:p>
             <a:pPr lvl="3"/>
             <a:r>
-              <a:rPr lang="en-US" smtClean="0"/>
+              <a:rPr lang="en-US"/>
               <a:t>Fourth level</a:t>
             </a:r>
           </a:p>
           <a:p>
             <a:pPr lvl="4"/>
             <a:r>
-              <a:rPr lang="en-US" smtClean="0"/>
+              <a:rPr lang="en-US"/>
               <a:t>Fifth level</a:t>
             </a:r>
-            <a:endParaRPr lang="en-US"/>
           </a:p>
         </p:txBody>
       </p:sp>
@@ -1308,38 +1313,37 @@
           <a:p>
             <a:pPr lvl="0"/>
             <a:r>
-              <a:rPr lang="en-US" smtClean="0"/>
+              <a:rPr lang="en-US"/>
               <a:t>Click to edit Master text styles</a:t>
             </a:r>
           </a:p>
           <a:p>
             <a:pPr lvl="1"/>
             <a:r>
-              <a:rPr lang="en-US" smtClean="0"/>
+              <a:rPr lang="en-US"/>
               <a:t>Second level</a:t>
             </a:r>
           </a:p>
           <a:p>
             <a:pPr lvl="2"/>
             <a:r>
-              <a:rPr lang="en-US" smtClean="0"/>
+              <a:rPr lang="en-US"/>
               <a:t>Third level</a:t>
             </a:r>
           </a:p>
           <a:p>
             <a:pPr lvl="3"/>
             <a:r>
-              <a:rPr lang="en-US" smtClean="0"/>
+              <a:rPr lang="en-US"/>
               <a:t>Fourth level</a:t>
             </a:r>
           </a:p>
           <a:p>
             <a:pPr lvl="4"/>
             <a:r>
-              <a:rPr lang="en-US" smtClean="0"/>
+              <a:rPr lang="en-US"/>
               <a:t>Fifth level</a:t>
             </a:r>
-            <a:endParaRPr lang="en-US"/>
           </a:p>
         </p:txBody>
       </p:sp>
@@ -1360,7 +1364,7 @@
           <a:p>
             <a:fld id="{5BCAD085-E8A6-8845-BD4E-CB4CCA059FC4}" type="datetimeFigureOut">
               <a:rPr lang="en-US" smtClean="0"/>
-              <a:t>1/27/13</a:t>
+              <a:t>5/18/2026</a:t>
             </a:fld>
             <a:endParaRPr lang="en-US"/>
           </a:p>
@@ -1458,10 +1462,9 @@
           </a:lstStyle>
           <a:p>
             <a:r>
-              <a:rPr lang="en-US" smtClean="0"/>
+              <a:rPr lang="en-US"/>
               <a:t>Click to edit Master title style</a:t>
             </a:r>
-            <a:endParaRPr lang="en-US"/>
           </a:p>
         </p:txBody>
       </p:sp>
@@ -1524,7 +1527,7 @@
           <a:p>
             <a:pPr lvl="0"/>
             <a:r>
-              <a:rPr lang="en-US" smtClean="0"/>
+              <a:rPr lang="en-US"/>
               <a:t>Click to edit Master text styles</a:t>
             </a:r>
           </a:p>
@@ -1580,38 +1583,37 @@
           <a:p>
             <a:pPr lvl="0"/>
             <a:r>
-              <a:rPr lang="en-US" smtClean="0"/>
+              <a:rPr lang="en-US"/>
               <a:t>Click to edit Master text styles</a:t>
             </a:r>
           </a:p>
           <a:p>
             <a:pPr lvl="1"/>
             <a:r>
-              <a:rPr lang="en-US" smtClean="0"/>
+              <a:rPr lang="en-US"/>
               <a:t>Second level</a:t>
             </a:r>
           </a:p>
           <a:p>
             <a:pPr lvl="2"/>
             <a:r>
-              <a:rPr lang="en-US" smtClean="0"/>
+              <a:rPr lang="en-US"/>
               <a:t>Third level</a:t>
             </a:r>
           </a:p>
           <a:p>
             <a:pPr lvl="3"/>
             <a:r>
-              <a:rPr lang="en-US" smtClean="0"/>
+              <a:rPr lang="en-US"/>
               <a:t>Fourth level</a:t>
             </a:r>
           </a:p>
           <a:p>
             <a:pPr lvl="4"/>
             <a:r>
-              <a:rPr lang="en-US" smtClean="0"/>
+              <a:rPr lang="en-US"/>
               <a:t>Fifth level</a:t>
             </a:r>
-            <a:endParaRPr lang="en-US"/>
           </a:p>
         </p:txBody>
       </p:sp>
@@ -1674,7 +1676,7 @@
           <a:p>
             <a:pPr lvl="0"/>
             <a:r>
-              <a:rPr lang="en-US" smtClean="0"/>
+              <a:rPr lang="en-US"/>
               <a:t>Click to edit Master text styles</a:t>
             </a:r>
           </a:p>
@@ -1730,38 +1732,37 @@
           <a:p>
             <a:pPr lvl="0"/>
             <a:r>
-              <a:rPr lang="en-US" smtClean="0"/>
+              <a:rPr lang="en-US"/>
               <a:t>Click to edit Master text styles</a:t>
             </a:r>
           </a:p>
           <a:p>
             <a:pPr lvl="1"/>
             <a:r>
-              <a:rPr lang="en-US" smtClean="0"/>
+              <a:rPr lang="en-US"/>
               <a:t>Second level</a:t>
             </a:r>
           </a:p>
           <a:p>
             <a:pPr lvl="2"/>
             <a:r>
-              <a:rPr lang="en-US" smtClean="0"/>
+              <a:rPr lang="en-US"/>
               <a:t>Third level</a:t>
             </a:r>
           </a:p>
           <a:p>
             <a:pPr lvl="3"/>
             <a:r>
-              <a:rPr lang="en-US" smtClean="0"/>
+              <a:rPr lang="en-US"/>
               <a:t>Fourth level</a:t>
             </a:r>
           </a:p>
           <a:p>
             <a:pPr lvl="4"/>
             <a:r>
-              <a:rPr lang="en-US" smtClean="0"/>
+              <a:rPr lang="en-US"/>
               <a:t>Fifth level</a:t>
             </a:r>
-            <a:endParaRPr lang="en-US"/>
           </a:p>
         </p:txBody>
       </p:sp>
@@ -1782,7 +1783,7 @@
           <a:p>
             <a:fld id="{5BCAD085-E8A6-8845-BD4E-CB4CCA059FC4}" type="datetimeFigureOut">
               <a:rPr lang="en-US" smtClean="0"/>
-              <a:t>1/27/13</a:t>
+              <a:t>5/18/2026</a:t>
             </a:fld>
             <a:endParaRPr lang="en-US"/>
           </a:p>
@@ -1876,10 +1877,9 @@
           <a:lstStyle/>
           <a:p>
             <a:r>
-              <a:rPr lang="en-US" smtClean="0"/>
+              <a:rPr lang="en-US"/>
               <a:t>Click to edit Master title style</a:t>
             </a:r>
-            <a:endParaRPr lang="en-US"/>
           </a:p>
         </p:txBody>
       </p:sp>
@@ -1900,7 +1900,7 @@
           <a:p>
             <a:fld id="{5BCAD085-E8A6-8845-BD4E-CB4CCA059FC4}" type="datetimeFigureOut">
               <a:rPr lang="en-US" smtClean="0"/>
-              <a:t>1/27/13</a:t>
+              <a:t>5/18/2026</a:t>
             </a:fld>
             <a:endParaRPr lang="en-US"/>
           </a:p>
@@ -1995,7 +1995,7 @@
           <a:p>
             <a:fld id="{5BCAD085-E8A6-8845-BD4E-CB4CCA059FC4}" type="datetimeFigureOut">
               <a:rPr lang="en-US" smtClean="0"/>
-              <a:t>1/27/13</a:t>
+              <a:t>5/18/2026</a:t>
             </a:fld>
             <a:endParaRPr lang="en-US"/>
           </a:p>
@@ -2098,10 +2098,9 @@
           </a:lstStyle>
           <a:p>
             <a:r>
-              <a:rPr lang="en-US" smtClean="0"/>
+              <a:rPr lang="en-US"/>
               <a:t>Click to edit Master title style</a:t>
             </a:r>
-            <a:endParaRPr lang="en-US"/>
           </a:p>
         </p:txBody>
       </p:sp>
@@ -2155,38 +2154,37 @@
           <a:p>
             <a:pPr lvl="0"/>
             <a:r>
-              <a:rPr lang="en-US" smtClean="0"/>
+              <a:rPr lang="en-US"/>
               <a:t>Click to edit Master text styles</a:t>
             </a:r>
           </a:p>
           <a:p>
             <a:pPr lvl="1"/>
             <a:r>
-              <a:rPr lang="en-US" smtClean="0"/>
+              <a:rPr lang="en-US"/>
               <a:t>Second level</a:t>
             </a:r>
           </a:p>
           <a:p>
             <a:pPr lvl="2"/>
             <a:r>
-              <a:rPr lang="en-US" smtClean="0"/>
+              <a:rPr lang="en-US"/>
               <a:t>Third level</a:t>
             </a:r>
           </a:p>
           <a:p>
             <a:pPr lvl="3"/>
             <a:r>
-              <a:rPr lang="en-US" smtClean="0"/>
+              <a:rPr lang="en-US"/>
               <a:t>Fourth level</a:t>
             </a:r>
           </a:p>
           <a:p>
             <a:pPr lvl="4"/>
             <a:r>
-              <a:rPr lang="en-US" smtClean="0"/>
+              <a:rPr lang="en-US"/>
               <a:t>Fifth level</a:t>
             </a:r>
-            <a:endParaRPr lang="en-US"/>
           </a:p>
         </p:txBody>
       </p:sp>
@@ -2249,7 +2247,7 @@
           <a:p>
             <a:pPr lvl="0"/>
             <a:r>
-              <a:rPr lang="en-US" smtClean="0"/>
+              <a:rPr lang="en-US"/>
               <a:t>Click to edit Master text styles</a:t>
             </a:r>
           </a:p>
@@ -2272,7 +2270,7 @@
           <a:p>
             <a:fld id="{5BCAD085-E8A6-8845-BD4E-CB4CCA059FC4}" type="datetimeFigureOut">
               <a:rPr lang="en-US" smtClean="0"/>
-              <a:t>1/27/13</a:t>
+              <a:t>5/18/2026</a:t>
             </a:fld>
             <a:endParaRPr lang="en-US"/>
           </a:p>
@@ -2375,10 +2373,9 @@
           </a:lstStyle>
           <a:p>
             <a:r>
-              <a:rPr lang="en-US" smtClean="0"/>
+              <a:rPr lang="en-US"/>
               <a:t>Click to edit Master title style</a:t>
             </a:r>
-            <a:endParaRPr lang="en-US"/>
           </a:p>
         </p:txBody>
       </p:sp>
@@ -2502,7 +2499,7 @@
           <a:p>
             <a:pPr lvl="0"/>
             <a:r>
-              <a:rPr lang="en-US" smtClean="0"/>
+              <a:rPr lang="en-US"/>
               <a:t>Click to edit Master text styles</a:t>
             </a:r>
           </a:p>
@@ -2525,7 +2522,7 @@
           <a:p>
             <a:fld id="{5BCAD085-E8A6-8845-BD4E-CB4CCA059FC4}" type="datetimeFigureOut">
               <a:rPr lang="en-US" smtClean="0"/>
-              <a:t>1/27/13</a:t>
+              <a:t>5/18/2026</a:t>
             </a:fld>
             <a:endParaRPr lang="en-US"/>
           </a:p>
@@ -2634,10 +2631,9 @@
           <a:lstStyle/>
           <a:p>
             <a:r>
-              <a:rPr lang="en-US" smtClean="0"/>
+              <a:rPr lang="en-US"/>
               <a:t>Click to edit Master title style</a:t>
             </a:r>
-            <a:endParaRPr lang="en-US"/>
           </a:p>
         </p:txBody>
       </p:sp>
@@ -2668,38 +2664,37 @@
           <a:p>
             <a:pPr lvl="0"/>
             <a:r>
-              <a:rPr lang="en-US" smtClean="0"/>
+              <a:rPr lang="en-US"/>
               <a:t>Click to edit Master text styles</a:t>
             </a:r>
           </a:p>
           <a:p>
             <a:pPr lvl="1"/>
             <a:r>
-              <a:rPr lang="en-US" smtClean="0"/>
+              <a:rPr lang="en-US"/>
               <a:t>Second level</a:t>
             </a:r>
           </a:p>
           <a:p>
             <a:pPr lvl="2"/>
             <a:r>
-              <a:rPr lang="en-US" smtClean="0"/>
+              <a:rPr lang="en-US"/>
               <a:t>Third level</a:t>
             </a:r>
           </a:p>
           <a:p>
             <a:pPr lvl="3"/>
             <a:r>
-              <a:rPr lang="en-US" smtClean="0"/>
+              <a:rPr lang="en-US"/>
               <a:t>Fourth level</a:t>
             </a:r>
           </a:p>
           <a:p>
             <a:pPr lvl="4"/>
             <a:r>
-              <a:rPr lang="en-US" smtClean="0"/>
+              <a:rPr lang="en-US"/>
               <a:t>Fifth level</a:t>
             </a:r>
-            <a:endParaRPr lang="en-US"/>
           </a:p>
         </p:txBody>
       </p:sp>
@@ -2738,7 +2733,7 @@
           <a:p>
             <a:fld id="{5BCAD085-E8A6-8845-BD4E-CB4CCA059FC4}" type="datetimeFigureOut">
               <a:rPr lang="en-US" smtClean="0"/>
-              <a:t>1/27/13</a:t>
+              <a:t>5/18/2026</a:t>
             </a:fld>
             <a:endParaRPr lang="en-US"/>
           </a:p>
@@ -3097,7 +3092,7 @@
 </file>
 
 <file path=ppt/slides/slide1.xml><?xml version="1.0" encoding="utf-8"?>
-<p:sld xmlns:a="http://schemas.openxmlformats.org/drawingml/2006/main" xmlns:p="http://schemas.openxmlformats.org/presentationml/2006/main" xmlns:r="http://schemas.openxmlformats.org/officeDocument/2006/relationships">
+<p:sld xmlns:a="http://schemas.openxmlformats.org/drawingml/2006/main" xmlns:r="http://schemas.openxmlformats.org/officeDocument/2006/relationships" xmlns:p="http://schemas.openxmlformats.org/presentationml/2006/main">
   <p:cSld>
     <p:spTree>
       <p:nvGrpSpPr>
@@ -3105,7 +3100,14 @@
         <p:cNvGrpSpPr/>
         <p:nvPr/>
       </p:nvGrpSpPr>
-      <p:grpSpPr/>
+      <p:grpSpPr>
+        <a:xfrm>
+          <a:off x="0" y="0"/>
+          <a:ext cx="0" cy="0"/>
+          <a:chOff x="0" y="0"/>
+          <a:chExt cx="0" cy="0"/>
+        </a:xfrm>
+      </p:grpSpPr>
       <p:sp>
         <p:nvSpPr>
           <p:cNvPr id="2" name="Rectangle 1"/>
@@ -3146,6 +3148,7 @@
           <a:lstStyle/>
           <a:p>
             <a:pPr algn="ctr"/>
+            <a:endParaRPr/>
           </a:p>
         </p:txBody>
       </p:sp>
@@ -3189,6 +3192,7 @@
           <a:lstStyle/>
           <a:p>
             <a:pPr algn="ctr"/>
+            <a:endParaRPr/>
           </a:p>
         </p:txBody>
       </p:sp>
@@ -3232,6 +3236,7 @@
           <a:lstStyle/>
           <a:p>
             <a:pPr algn="ctr"/>
+            <a:endParaRPr/>
           </a:p>
         </p:txBody>
       </p:sp>
@@ -3252,7 +3257,7 @@
           <a:noFill/>
         </p:spPr>
         <p:txBody>
-          <a:bodyPr wrap="square" tIns="0" bIns="0" lIns="0" rIns="0">
+          <a:bodyPr wrap="square" lIns="0" tIns="0" rIns="0" bIns="0">
             <a:spAutoFit/>
           </a:bodyPr>
           <a:lstStyle/>
@@ -3287,7 +3292,7 @@
           <a:noFill/>
         </p:spPr>
         <p:txBody>
-          <a:bodyPr wrap="square" tIns="0" bIns="0" lIns="0" rIns="0">
+          <a:bodyPr wrap="square" lIns="0" tIns="0" rIns="0" bIns="0">
             <a:spAutoFit/>
           </a:bodyPr>
           <a:lstStyle/>
@@ -3345,6 +3350,7 @@
           <a:lstStyle/>
           <a:p>
             <a:pPr algn="ctr"/>
+            <a:endParaRPr/>
           </a:p>
         </p:txBody>
       </p:sp>
@@ -3365,7 +3371,7 @@
           <a:noFill/>
         </p:spPr>
         <p:txBody>
-          <a:bodyPr wrap="square" tIns="0" bIns="0" lIns="0" rIns="0">
+          <a:bodyPr wrap="square" lIns="0" tIns="0" rIns="0" bIns="0">
             <a:spAutoFit/>
           </a:bodyPr>
           <a:lstStyle/>
@@ -3400,7 +3406,7 @@
           <a:noFill/>
         </p:spPr>
         <p:txBody>
-          <a:bodyPr wrap="square" tIns="0" bIns="0" lIns="0" rIns="0">
+          <a:bodyPr wrap="square" lIns="0" tIns="0" rIns="0" bIns="0">
             <a:spAutoFit/>
           </a:bodyPr>
           <a:lstStyle/>
@@ -3427,7 +3433,7 @@
 </file>
 
 <file path=ppt/slides/slide10.xml><?xml version="1.0" encoding="utf-8"?>
-<p:sld xmlns:a="http://schemas.openxmlformats.org/drawingml/2006/main" xmlns:p="http://schemas.openxmlformats.org/presentationml/2006/main" xmlns:r="http://schemas.openxmlformats.org/officeDocument/2006/relationships">
+<p:sld xmlns:a="http://schemas.openxmlformats.org/drawingml/2006/main" xmlns:r="http://schemas.openxmlformats.org/officeDocument/2006/relationships" xmlns:p="http://schemas.openxmlformats.org/presentationml/2006/main">
   <p:cSld>
     <p:spTree>
       <p:nvGrpSpPr>
@@ -3435,7 +3441,14 @@
         <p:cNvGrpSpPr/>
         <p:nvPr/>
       </p:nvGrpSpPr>
-      <p:grpSpPr/>
+      <p:grpSpPr>
+        <a:xfrm>
+          <a:off x="0" y="0"/>
+          <a:ext cx="0" cy="0"/>
+          <a:chOff x="0" y="0"/>
+          <a:chExt cx="0" cy="0"/>
+        </a:xfrm>
+      </p:grpSpPr>
       <p:sp>
         <p:nvSpPr>
           <p:cNvPr id="2" name="Rectangle 1"/>
@@ -3476,6 +3489,7 @@
           <a:lstStyle/>
           <a:p>
             <a:pPr algn="ctr"/>
+            <a:endParaRPr/>
           </a:p>
         </p:txBody>
       </p:sp>
@@ -3496,7 +3510,7 @@
           <a:noFill/>
         </p:spPr>
         <p:txBody>
-          <a:bodyPr wrap="square" tIns="0" bIns="0" lIns="0" rIns="0">
+          <a:bodyPr wrap="square" lIns="0" tIns="0" rIns="0" bIns="0">
             <a:spAutoFit/>
           </a:bodyPr>
           <a:lstStyle/>
@@ -3554,6 +3568,7 @@
           <a:lstStyle/>
           <a:p>
             <a:pPr algn="ctr"/>
+            <a:endParaRPr/>
           </a:p>
         </p:txBody>
       </p:sp>
@@ -3574,7 +3589,7 @@
           <a:noFill/>
         </p:spPr>
         <p:txBody>
-          <a:bodyPr wrap="square" tIns="0" bIns="0" lIns="0" rIns="0">
+          <a:bodyPr wrap="square" lIns="0" tIns="0" rIns="0" bIns="0">
             <a:spAutoFit/>
           </a:bodyPr>
           <a:lstStyle/>
@@ -3601,7 +3616,7 @@
 </file>
 
 <file path=ppt/slides/slide11.xml><?xml version="1.0" encoding="utf-8"?>
-<p:sld xmlns:a="http://schemas.openxmlformats.org/drawingml/2006/main" xmlns:p="http://schemas.openxmlformats.org/presentationml/2006/main" xmlns:r="http://schemas.openxmlformats.org/officeDocument/2006/relationships">
+<p:sld xmlns:a="http://schemas.openxmlformats.org/drawingml/2006/main" xmlns:r="http://schemas.openxmlformats.org/officeDocument/2006/relationships" xmlns:p="http://schemas.openxmlformats.org/presentationml/2006/main">
   <p:cSld>
     <p:spTree>
       <p:nvGrpSpPr>
@@ -3609,7 +3624,14 @@
         <p:cNvGrpSpPr/>
         <p:nvPr/>
       </p:nvGrpSpPr>
-      <p:grpSpPr/>
+      <p:grpSpPr>
+        <a:xfrm>
+          <a:off x="0" y="0"/>
+          <a:ext cx="0" cy="0"/>
+          <a:chOff x="0" y="0"/>
+          <a:chExt cx="0" cy="0"/>
+        </a:xfrm>
+      </p:grpSpPr>
       <p:sp>
         <p:nvSpPr>
           <p:cNvPr id="2" name="Rectangle 1"/>
@@ -3650,6 +3672,7 @@
           <a:lstStyle/>
           <a:p>
             <a:pPr algn="ctr"/>
+            <a:endParaRPr/>
           </a:p>
         </p:txBody>
       </p:sp>
@@ -3689,7 +3712,7 @@
           </a:fontRef>
         </p:style>
         <p:txBody>
-          <a:bodyPr rtlCol="0" anchor="ctr" wrap="none" tIns="0" bIns="0" lIns="381600" rIns="381600"/>
+          <a:bodyPr wrap="none" lIns="381600" tIns="0" rIns="381600" bIns="0" rtlCol="0" anchor="ctr"/>
           <a:lstStyle/>
           <a:p>
             <a:pPr algn="l"/>
@@ -3745,6 +3768,7 @@
           <a:lstStyle/>
           <a:p>
             <a:pPr algn="ctr"/>
+            <a:endParaRPr/>
           </a:p>
         </p:txBody>
       </p:sp>
@@ -3765,7 +3789,7 @@
           <a:noFill/>
         </p:spPr>
         <p:txBody>
-          <a:bodyPr wrap="square" tIns="0" bIns="0" lIns="0" rIns="0">
+          <a:bodyPr wrap="square" lIns="0" tIns="0" rIns="0" bIns="0">
             <a:spAutoFit/>
           </a:bodyPr>
           <a:lstStyle/>
@@ -3828,6 +3852,7 @@
           <a:lstStyle/>
           <a:p>
             <a:pPr algn="ctr"/>
+            <a:endParaRPr/>
           </a:p>
         </p:txBody>
       </p:sp>
@@ -3848,7 +3873,7 @@
           <a:noFill/>
         </p:spPr>
         <p:txBody>
-          <a:bodyPr wrap="square" tIns="0" bIns="0" lIns="0" rIns="0">
+          <a:bodyPr wrap="square" lIns="0" tIns="0" rIns="0" bIns="0">
             <a:spAutoFit/>
           </a:bodyPr>
           <a:lstStyle/>
@@ -3875,7 +3900,7 @@
 </file>
 
 <file path=ppt/slides/slide12.xml><?xml version="1.0" encoding="utf-8"?>
-<p:sld xmlns:a="http://schemas.openxmlformats.org/drawingml/2006/main" xmlns:p="http://schemas.openxmlformats.org/presentationml/2006/main" xmlns:r="http://schemas.openxmlformats.org/officeDocument/2006/relationships">
+<p:sld xmlns:a="http://schemas.openxmlformats.org/drawingml/2006/main" xmlns:r="http://schemas.openxmlformats.org/officeDocument/2006/relationships" xmlns:p="http://schemas.openxmlformats.org/presentationml/2006/main">
   <p:cSld>
     <p:spTree>
       <p:nvGrpSpPr>
@@ -3883,7 +3908,14 @@
         <p:cNvGrpSpPr/>
         <p:nvPr/>
       </p:nvGrpSpPr>
-      <p:grpSpPr/>
+      <p:grpSpPr>
+        <a:xfrm>
+          <a:off x="0" y="0"/>
+          <a:ext cx="0" cy="0"/>
+          <a:chOff x="0" y="0"/>
+          <a:chExt cx="0" cy="0"/>
+        </a:xfrm>
+      </p:grpSpPr>
       <p:sp>
         <p:nvSpPr>
           <p:cNvPr id="2" name="Rectangle 1"/>
@@ -3924,6 +3956,7 @@
           <a:lstStyle/>
           <a:p>
             <a:pPr algn="ctr"/>
+            <a:endParaRPr/>
           </a:p>
         </p:txBody>
       </p:sp>
@@ -3963,7 +3996,7 @@
           </a:fontRef>
         </p:style>
         <p:txBody>
-          <a:bodyPr rtlCol="0" anchor="ctr" wrap="none" tIns="0" bIns="0" lIns="381600" rIns="381600"/>
+          <a:bodyPr wrap="none" lIns="381600" tIns="0" rIns="381600" bIns="0" rtlCol="0" anchor="ctr"/>
           <a:lstStyle/>
           <a:p>
             <a:pPr algn="l"/>
@@ -3996,7 +4029,7 @@
           <a:noFill/>
         </p:spPr>
         <p:txBody>
-          <a:bodyPr wrap="square" tIns="0" bIns="0" lIns="0" rIns="0">
+          <a:bodyPr wrap="square" lIns="0" tIns="0" rIns="0" bIns="0">
             <a:spAutoFit/>
           </a:bodyPr>
           <a:lstStyle/>
@@ -4052,7 +4085,7 @@
           </a:fontRef>
         </p:style>
         <p:txBody>
-          <a:bodyPr rtlCol="0" anchor="t" wrap="none" tIns="108000" bIns="108000" lIns="144000" rIns="144000"/>
+          <a:bodyPr wrap="none" lIns="144000" tIns="108000" rIns="144000" bIns="108000" rtlCol="0" anchor="t"/>
           <a:lstStyle/>
           <a:p>
             <a:pPr algn="l"/>
@@ -4104,15 +4137,12 @@
           </a:p>
           <a:p>
             <a:pPr algn="l"/>
-            <a:r>
-              <a:rPr sz="1300">
-                <a:solidFill>
-                  <a:srgbClr val="FFFFFF"/>
-                </a:solidFill>
-                <a:latin typeface="Courier New"/>
-              </a:rPr>
-              <a:t/>
-            </a:r>
+            <a:endParaRPr sz="1300">
+              <a:solidFill>
+                <a:srgbClr val="FFFFFF"/>
+              </a:solidFill>
+              <a:latin typeface="Courier New"/>
+            </a:endParaRPr>
           </a:p>
           <a:p>
             <a:pPr algn="l"/>
@@ -4193,7 +4223,7 @@
           <a:noFill/>
         </p:spPr>
         <p:txBody>
-          <a:bodyPr wrap="square" tIns="0" bIns="0" lIns="0" rIns="0">
+          <a:bodyPr wrap="square" lIns="0" tIns="0" rIns="0" bIns="0">
             <a:spAutoFit/>
           </a:bodyPr>
           <a:lstStyle/>
@@ -4220,7 +4250,7 @@
 </file>
 
 <file path=ppt/slides/slide13.xml><?xml version="1.0" encoding="utf-8"?>
-<p:sld xmlns:a="http://schemas.openxmlformats.org/drawingml/2006/main" xmlns:p="http://schemas.openxmlformats.org/presentationml/2006/main" xmlns:r="http://schemas.openxmlformats.org/officeDocument/2006/relationships">
+<p:sld xmlns:a="http://schemas.openxmlformats.org/drawingml/2006/main" xmlns:r="http://schemas.openxmlformats.org/officeDocument/2006/relationships" xmlns:p="http://schemas.openxmlformats.org/presentationml/2006/main">
   <p:cSld>
     <p:spTree>
       <p:nvGrpSpPr>
@@ -4228,7 +4258,14 @@
         <p:cNvGrpSpPr/>
         <p:nvPr/>
       </p:nvGrpSpPr>
-      <p:grpSpPr/>
+      <p:grpSpPr>
+        <a:xfrm>
+          <a:off x="0" y="0"/>
+          <a:ext cx="0" cy="0"/>
+          <a:chOff x="0" y="0"/>
+          <a:chExt cx="0" cy="0"/>
+        </a:xfrm>
+      </p:grpSpPr>
       <p:sp>
         <p:nvSpPr>
           <p:cNvPr id="2" name="Rectangle 1"/>
@@ -4269,6 +4306,7 @@
           <a:lstStyle/>
           <a:p>
             <a:pPr algn="ctr"/>
+            <a:endParaRPr/>
           </a:p>
         </p:txBody>
       </p:sp>
@@ -4289,7 +4327,7 @@
           <a:noFill/>
         </p:spPr>
         <p:txBody>
-          <a:bodyPr wrap="square" tIns="0" bIns="0" lIns="0" rIns="0">
+          <a:bodyPr wrap="square" lIns="0" tIns="0" rIns="0" bIns="0">
             <a:spAutoFit/>
           </a:bodyPr>
           <a:lstStyle/>
@@ -4347,6 +4385,7 @@
           <a:lstStyle/>
           <a:p>
             <a:pPr algn="ctr"/>
+            <a:endParaRPr/>
           </a:p>
         </p:txBody>
       </p:sp>
@@ -4367,7 +4406,7 @@
           <a:noFill/>
         </p:spPr>
         <p:txBody>
-          <a:bodyPr wrap="square" tIns="0" bIns="0" lIns="0" rIns="0">
+          <a:bodyPr wrap="square" lIns="0" tIns="0" rIns="0" bIns="0">
             <a:spAutoFit/>
           </a:bodyPr>
           <a:lstStyle/>
@@ -4394,7 +4433,7 @@
 </file>
 
 <file path=ppt/slides/slide14.xml><?xml version="1.0" encoding="utf-8"?>
-<p:sld xmlns:a="http://schemas.openxmlformats.org/drawingml/2006/main" xmlns:p="http://schemas.openxmlformats.org/presentationml/2006/main" xmlns:r="http://schemas.openxmlformats.org/officeDocument/2006/relationships">
+<p:sld xmlns:a="http://schemas.openxmlformats.org/drawingml/2006/main" xmlns:r="http://schemas.openxmlformats.org/officeDocument/2006/relationships" xmlns:p="http://schemas.openxmlformats.org/presentationml/2006/main">
   <p:cSld>
     <p:spTree>
       <p:nvGrpSpPr>
@@ -4402,7 +4441,14 @@
         <p:cNvGrpSpPr/>
         <p:nvPr/>
       </p:nvGrpSpPr>
-      <p:grpSpPr/>
+      <p:grpSpPr>
+        <a:xfrm>
+          <a:off x="0" y="0"/>
+          <a:ext cx="0" cy="0"/>
+          <a:chOff x="0" y="0"/>
+          <a:chExt cx="0" cy="0"/>
+        </a:xfrm>
+      </p:grpSpPr>
       <p:sp>
         <p:nvSpPr>
           <p:cNvPr id="2" name="Rectangle 1"/>
@@ -4443,6 +4489,7 @@
           <a:lstStyle/>
           <a:p>
             <a:pPr algn="ctr"/>
+            <a:endParaRPr/>
           </a:p>
         </p:txBody>
       </p:sp>
@@ -4482,7 +4529,7 @@
           </a:fontRef>
         </p:style>
         <p:txBody>
-          <a:bodyPr rtlCol="0" anchor="ctr" wrap="none" tIns="0" bIns="0" lIns="381600" rIns="381600"/>
+          <a:bodyPr wrap="none" lIns="381600" tIns="0" rIns="381600" bIns="0" rtlCol="0" anchor="ctr"/>
           <a:lstStyle/>
           <a:p>
             <a:pPr algn="l"/>
@@ -4538,6 +4585,7 @@
           <a:lstStyle/>
           <a:p>
             <a:pPr algn="ctr"/>
+            <a:endParaRPr/>
           </a:p>
         </p:txBody>
       </p:sp>
@@ -4558,7 +4606,7 @@
           <a:noFill/>
         </p:spPr>
         <p:txBody>
-          <a:bodyPr wrap="square" tIns="0" bIns="0" lIns="0" rIns="0">
+          <a:bodyPr wrap="square" lIns="0" tIns="0" rIns="0" bIns="0">
             <a:spAutoFit/>
           </a:bodyPr>
           <a:lstStyle/>
@@ -4621,6 +4669,7 @@
           <a:lstStyle/>
           <a:p>
             <a:pPr algn="ctr"/>
+            <a:endParaRPr/>
           </a:p>
         </p:txBody>
       </p:sp>
@@ -4641,7 +4690,7 @@
           <a:noFill/>
         </p:spPr>
         <p:txBody>
-          <a:bodyPr wrap="square" tIns="0" bIns="0" lIns="0" rIns="0">
+          <a:bodyPr wrap="square" lIns="0" tIns="0" rIns="0" bIns="0">
             <a:spAutoFit/>
           </a:bodyPr>
           <a:lstStyle/>
@@ -4668,7 +4717,7 @@
 </file>
 
 <file path=ppt/slides/slide15.xml><?xml version="1.0" encoding="utf-8"?>
-<p:sld xmlns:a="http://schemas.openxmlformats.org/drawingml/2006/main" xmlns:p="http://schemas.openxmlformats.org/presentationml/2006/main" xmlns:r="http://schemas.openxmlformats.org/officeDocument/2006/relationships">
+<p:sld xmlns:a="http://schemas.openxmlformats.org/drawingml/2006/main" xmlns:r="http://schemas.openxmlformats.org/officeDocument/2006/relationships" xmlns:p="http://schemas.openxmlformats.org/presentationml/2006/main">
   <p:cSld>
     <p:spTree>
       <p:nvGrpSpPr>
@@ -4676,7 +4725,14 @@
         <p:cNvGrpSpPr/>
         <p:nvPr/>
       </p:nvGrpSpPr>
-      <p:grpSpPr/>
+      <p:grpSpPr>
+        <a:xfrm>
+          <a:off x="0" y="0"/>
+          <a:ext cx="0" cy="0"/>
+          <a:chOff x="0" y="0"/>
+          <a:chExt cx="0" cy="0"/>
+        </a:xfrm>
+      </p:grpSpPr>
       <p:sp>
         <p:nvSpPr>
           <p:cNvPr id="2" name="Rectangle 1"/>
@@ -4717,6 +4773,7 @@
           <a:lstStyle/>
           <a:p>
             <a:pPr algn="ctr"/>
+            <a:endParaRPr/>
           </a:p>
         </p:txBody>
       </p:sp>
@@ -4737,7 +4794,7 @@
           <a:noFill/>
         </p:spPr>
         <p:txBody>
-          <a:bodyPr wrap="square" tIns="0" bIns="0" lIns="0" rIns="0">
+          <a:bodyPr wrap="square" lIns="0" tIns="0" rIns="0" bIns="0">
             <a:spAutoFit/>
           </a:bodyPr>
           <a:lstStyle/>
@@ -4795,6 +4852,7 @@
           <a:lstStyle/>
           <a:p>
             <a:pPr algn="ctr"/>
+            <a:endParaRPr/>
           </a:p>
         </p:txBody>
       </p:sp>
@@ -4807,7 +4865,7 @@
 </file>
 
 <file path=ppt/slides/slide16.xml><?xml version="1.0" encoding="utf-8"?>
-<p:sld xmlns:a="http://schemas.openxmlformats.org/drawingml/2006/main" xmlns:p="http://schemas.openxmlformats.org/presentationml/2006/main" xmlns:r="http://schemas.openxmlformats.org/officeDocument/2006/relationships">
+<p:sld xmlns:a="http://schemas.openxmlformats.org/drawingml/2006/main" xmlns:r="http://schemas.openxmlformats.org/officeDocument/2006/relationships" xmlns:p="http://schemas.openxmlformats.org/presentationml/2006/main">
   <p:cSld>
     <p:spTree>
       <p:nvGrpSpPr>
@@ -4815,7 +4873,14 @@
         <p:cNvGrpSpPr/>
         <p:nvPr/>
       </p:nvGrpSpPr>
-      <p:grpSpPr/>
+      <p:grpSpPr>
+        <a:xfrm>
+          <a:off x="0" y="0"/>
+          <a:ext cx="0" cy="0"/>
+          <a:chOff x="0" y="0"/>
+          <a:chExt cx="0" cy="0"/>
+        </a:xfrm>
+      </p:grpSpPr>
       <p:sp>
         <p:nvSpPr>
           <p:cNvPr id="2" name="Rectangle 1"/>
@@ -4856,6 +4921,7 @@
           <a:lstStyle/>
           <a:p>
             <a:pPr algn="ctr"/>
+            <a:endParaRPr/>
           </a:p>
         </p:txBody>
       </p:sp>
@@ -4895,7 +4961,7 @@
           </a:fontRef>
         </p:style>
         <p:txBody>
-          <a:bodyPr rtlCol="0" anchor="ctr" wrap="none" tIns="0" bIns="0" lIns="381600" rIns="381600"/>
+          <a:bodyPr wrap="none" lIns="381600" tIns="0" rIns="381600" bIns="0" rtlCol="0" anchor="ctr"/>
           <a:lstStyle/>
           <a:p>
             <a:pPr algn="l"/>
@@ -4919,7 +4985,7 @@
         </p:nvSpPr>
         <p:spPr>
           <a:xfrm>
-            <a:off x="360000" y="705600"/>
+            <a:off x="396000" y="580554"/>
             <a:ext cx="11473200" cy="5972400"/>
           </a:xfrm>
           <a:prstGeom prst="rect">
@@ -4949,7 +5015,7 @@
           </a:fontRef>
         </p:style>
         <p:txBody>
-          <a:bodyPr rtlCol="0" anchor="t" wrap="none" tIns="108000" bIns="108000" lIns="144000" rIns="144000"/>
+          <a:bodyPr wrap="none" lIns="144000" tIns="108000" rIns="144000" bIns="108000" rtlCol="0" anchor="t"/>
           <a:lstStyle/>
           <a:p>
             <a:pPr algn="l"/>
@@ -5082,49 +5148,6 @@
               </a:rPr>
               <a:t> ip ospf priority 0            ! escluso dalla election</a:t>
             </a:r>
-          </a:p>
-        </p:txBody>
-      </p:sp>
-      <p:sp>
-        <p:nvSpPr>
-          <p:cNvPr id="5" name="Rectangle 4"/>
-          <p:cNvSpPr/>
-          <p:nvPr/>
-        </p:nvSpPr>
-        <p:spPr>
-          <a:xfrm>
-            <a:off x="396000" y="1677600"/>
-            <a:ext cx="11401200" cy="216000"/>
-          </a:xfrm>
-          <a:prstGeom prst="rect">
-            <a:avLst/>
-          </a:prstGeom>
-          <a:solidFill>
-            <a:srgbClr val="4A3D00"/>
-          </a:solidFill>
-          <a:ln>
-            <a:noFill/>
-          </a:ln>
-        </p:spPr>
-        <p:style>
-          <a:lnRef idx="1">
-            <a:schemeClr val="accent1"/>
-          </a:lnRef>
-          <a:fillRef idx="3">
-            <a:schemeClr val="accent1"/>
-          </a:fillRef>
-          <a:effectRef idx="2">
-            <a:schemeClr val="accent1"/>
-          </a:effectRef>
-          <a:fontRef idx="minor">
-            <a:schemeClr val="lt1"/>
-          </a:fontRef>
-        </p:style>
-        <p:txBody>
-          <a:bodyPr rtlCol="0" anchor="ctr"/>
-          <a:lstStyle/>
-          <a:p>
-            <a:pPr algn="ctr"/>
           </a:p>
         </p:txBody>
       </p:sp>
@@ -5168,6 +5191,7 @@
           <a:lstStyle/>
           <a:p>
             <a:pPr algn="ctr"/>
+            <a:endParaRPr/>
           </a:p>
         </p:txBody>
       </p:sp>
@@ -5188,7 +5212,7 @@
           <a:noFill/>
         </p:spPr>
         <p:txBody>
-          <a:bodyPr wrap="square" tIns="0" bIns="0" lIns="0" rIns="0">
+          <a:bodyPr wrap="square" lIns="0" tIns="0" rIns="0" bIns="0">
             <a:spAutoFit/>
           </a:bodyPr>
           <a:lstStyle/>
@@ -5215,7 +5239,7 @@
 </file>
 
 <file path=ppt/slides/slide17.xml><?xml version="1.0" encoding="utf-8"?>
-<p:sld xmlns:a="http://schemas.openxmlformats.org/drawingml/2006/main" xmlns:p="http://schemas.openxmlformats.org/presentationml/2006/main" xmlns:r="http://schemas.openxmlformats.org/officeDocument/2006/relationships">
+<p:sld xmlns:a="http://schemas.openxmlformats.org/drawingml/2006/main" xmlns:r="http://schemas.openxmlformats.org/officeDocument/2006/relationships" xmlns:p="http://schemas.openxmlformats.org/presentationml/2006/main">
   <p:cSld>
     <p:spTree>
       <p:nvGrpSpPr>
@@ -5223,7 +5247,14 @@
         <p:cNvGrpSpPr/>
         <p:nvPr/>
       </p:nvGrpSpPr>
-      <p:grpSpPr/>
+      <p:grpSpPr>
+        <a:xfrm>
+          <a:off x="0" y="0"/>
+          <a:ext cx="0" cy="0"/>
+          <a:chOff x="0" y="0"/>
+          <a:chExt cx="0" cy="0"/>
+        </a:xfrm>
+      </p:grpSpPr>
       <p:sp>
         <p:nvSpPr>
           <p:cNvPr id="2" name="Rectangle 1"/>
@@ -5264,6 +5295,7 @@
           <a:lstStyle/>
           <a:p>
             <a:pPr algn="ctr"/>
+            <a:endParaRPr/>
           </a:p>
         </p:txBody>
       </p:sp>
@@ -5303,7 +5335,7 @@
           </a:fontRef>
         </p:style>
         <p:txBody>
-          <a:bodyPr rtlCol="0" anchor="ctr" wrap="none" tIns="0" bIns="0" lIns="381600" rIns="381600"/>
+          <a:bodyPr wrap="none" lIns="381600" tIns="0" rIns="381600" bIns="0" rtlCol="0" anchor="ctr"/>
           <a:lstStyle/>
           <a:p>
             <a:pPr algn="l"/>
@@ -5338,13 +5370,25 @@
                 <a:tableStyleId>{5C22544A-7EE6-4342-B048-85BDC9FD1C3A}</a:tableStyleId>
               </a:tblPr>
               <a:tblGrid>
-                <a:gridCol w="4091220"/>
-                <a:gridCol w="7597981"/>
+                <a:gridCol w="4091220">
+                  <a:extLst>
+                    <a:ext uri="{9D8B030D-6E8A-4147-A177-3AD203B41FA5}">
+                      <a16:colId xmlns:a16="http://schemas.microsoft.com/office/drawing/2014/main" val="20000"/>
+                    </a:ext>
+                  </a:extLst>
+                </a:gridCol>
+                <a:gridCol w="7597981">
+                  <a:extLst>
+                    <a:ext uri="{9D8B030D-6E8A-4147-A177-3AD203B41FA5}">
+                      <a16:colId xmlns:a16="http://schemas.microsoft.com/office/drawing/2014/main" val="20001"/>
+                    </a:ext>
+                  </a:extLst>
+                </a:gridCol>
               </a:tblGrid>
               <a:tr h="1212480">
                 <a:tc>
                   <a:txBody>
-                    <a:bodyPr wrap="square" anchor="ctr" tIns="63500" bIns="63500" lIns="101600" rIns="101600"/>
+                    <a:bodyPr/>
                     <a:lstStyle/>
                     <a:p>
                       <a:pPr algn="ctr"/>
@@ -5367,7 +5411,7 @@
                 </a:tc>
                 <a:tc>
                   <a:txBody>
-                    <a:bodyPr wrap="square" anchor="ctr" tIns="63500" bIns="63500" lIns="101600" rIns="101600"/>
+                    <a:bodyPr/>
                     <a:lstStyle/>
                     <a:p>
                       <a:pPr algn="ctr"/>
@@ -5388,11 +5432,16 @@
                     </a:solidFill>
                   </a:tcPr>
                 </a:tc>
+                <a:extLst>
+                  <a:ext uri="{0D108BD9-81ED-4DB2-BD59-A6C34878D82A}">
+                    <a16:rowId xmlns:a16="http://schemas.microsoft.com/office/drawing/2014/main" val="10000"/>
+                  </a:ext>
+                </a:extLst>
               </a:tr>
               <a:tr h="1212480">
                 <a:tc>
                   <a:txBody>
-                    <a:bodyPr wrap="square" anchor="ctr" tIns="63500" bIns="63500" lIns="101600" rIns="101600"/>
+                    <a:bodyPr/>
                     <a:lstStyle/>
                     <a:p>
                       <a:pPr algn="l"/>
@@ -5415,7 +5464,7 @@
                 </a:tc>
                 <a:tc>
                   <a:txBody>
-                    <a:bodyPr wrap="square" anchor="ctr" tIns="63500" bIns="63500" lIns="101600" rIns="101600"/>
+                    <a:bodyPr/>
                     <a:lstStyle/>
                     <a:p>
                       <a:pPr algn="l"/>
@@ -5436,11 +5485,16 @@
                     </a:solidFill>
                   </a:tcPr>
                 </a:tc>
+                <a:extLst>
+                  <a:ext uri="{0D108BD9-81ED-4DB2-BD59-A6C34878D82A}">
+                    <a16:rowId xmlns:a16="http://schemas.microsoft.com/office/drawing/2014/main" val="10001"/>
+                  </a:ext>
+                </a:extLst>
               </a:tr>
               <a:tr h="1212480">
                 <a:tc>
                   <a:txBody>
-                    <a:bodyPr wrap="square" anchor="ctr" tIns="63500" bIns="63500" lIns="101600" rIns="101600"/>
+                    <a:bodyPr/>
                     <a:lstStyle/>
                     <a:p>
                       <a:pPr algn="l"/>
@@ -5463,7 +5517,7 @@
                 </a:tc>
                 <a:tc>
                   <a:txBody>
-                    <a:bodyPr wrap="square" anchor="ctr" tIns="63500" bIns="63500" lIns="101600" rIns="101600"/>
+                    <a:bodyPr/>
                     <a:lstStyle/>
                     <a:p>
                       <a:pPr algn="l"/>
@@ -5484,11 +5538,16 @@
                     </a:solidFill>
                   </a:tcPr>
                 </a:tc>
+                <a:extLst>
+                  <a:ext uri="{0D108BD9-81ED-4DB2-BD59-A6C34878D82A}">
+                    <a16:rowId xmlns:a16="http://schemas.microsoft.com/office/drawing/2014/main" val="10002"/>
+                  </a:ext>
+                </a:extLst>
               </a:tr>
               <a:tr h="1212480">
                 <a:tc>
                   <a:txBody>
-                    <a:bodyPr wrap="square" anchor="ctr" tIns="63500" bIns="63500" lIns="101600" rIns="101600"/>
+                    <a:bodyPr/>
                     <a:lstStyle/>
                     <a:p>
                       <a:pPr algn="l"/>
@@ -5511,7 +5570,7 @@
                 </a:tc>
                 <a:tc>
                   <a:txBody>
-                    <a:bodyPr wrap="square" anchor="ctr" tIns="63500" bIns="63500" lIns="101600" rIns="101600"/>
+                    <a:bodyPr/>
                     <a:lstStyle/>
                     <a:p>
                       <a:pPr algn="l"/>
@@ -5532,11 +5591,16 @@
                     </a:solidFill>
                   </a:tcPr>
                 </a:tc>
+                <a:extLst>
+                  <a:ext uri="{0D108BD9-81ED-4DB2-BD59-A6C34878D82A}">
+                    <a16:rowId xmlns:a16="http://schemas.microsoft.com/office/drawing/2014/main" val="10003"/>
+                  </a:ext>
+                </a:extLst>
               </a:tr>
               <a:tr h="1212481">
                 <a:tc>
                   <a:txBody>
-                    <a:bodyPr wrap="square" anchor="ctr" tIns="63500" bIns="63500" lIns="101600" rIns="101600"/>
+                    <a:bodyPr/>
                     <a:lstStyle/>
                     <a:p>
                       <a:pPr algn="l"/>
@@ -5559,7 +5623,7 @@
                 </a:tc>
                 <a:tc>
                   <a:txBody>
-                    <a:bodyPr wrap="square" anchor="ctr" tIns="63500" bIns="63500" lIns="101600" rIns="101600"/>
+                    <a:bodyPr/>
                     <a:lstStyle/>
                     <a:p>
                       <a:pPr algn="l"/>
@@ -5580,6 +5644,11 @@
                     </a:solidFill>
                   </a:tcPr>
                 </a:tc>
+                <a:extLst>
+                  <a:ext uri="{0D108BD9-81ED-4DB2-BD59-A6C34878D82A}">
+                    <a16:rowId xmlns:a16="http://schemas.microsoft.com/office/drawing/2014/main" val="10004"/>
+                  </a:ext>
+                </a:extLst>
               </a:tr>
             </a:tbl>
           </a:graphicData>
@@ -5594,7 +5663,7 @@
 </file>
 
 <file path=ppt/slides/slide18.xml><?xml version="1.0" encoding="utf-8"?>
-<p:sld xmlns:a="http://schemas.openxmlformats.org/drawingml/2006/main" xmlns:p="http://schemas.openxmlformats.org/presentationml/2006/main" xmlns:r="http://schemas.openxmlformats.org/officeDocument/2006/relationships">
+<p:sld xmlns:a="http://schemas.openxmlformats.org/drawingml/2006/main" xmlns:r="http://schemas.openxmlformats.org/officeDocument/2006/relationships" xmlns:p="http://schemas.openxmlformats.org/presentationml/2006/main">
   <p:cSld>
     <p:spTree>
       <p:nvGrpSpPr>
@@ -5602,7 +5671,14 @@
         <p:cNvGrpSpPr/>
         <p:nvPr/>
       </p:nvGrpSpPr>
-      <p:grpSpPr/>
+      <p:grpSpPr>
+        <a:xfrm>
+          <a:off x="0" y="0"/>
+          <a:ext cx="0" cy="0"/>
+          <a:chOff x="0" y="0"/>
+          <a:chExt cx="0" cy="0"/>
+        </a:xfrm>
+      </p:grpSpPr>
       <p:sp>
         <p:nvSpPr>
           <p:cNvPr id="2" name="Rectangle 1"/>
@@ -5643,6 +5719,7 @@
           <a:lstStyle/>
           <a:p>
             <a:pPr algn="ctr"/>
+            <a:endParaRPr/>
           </a:p>
         </p:txBody>
       </p:sp>
@@ -5682,7 +5759,7 @@
           </a:fontRef>
         </p:style>
         <p:txBody>
-          <a:bodyPr rtlCol="0" anchor="ctr" wrap="none" tIns="0" bIns="0" lIns="381600" rIns="381600"/>
+          <a:bodyPr wrap="none" lIns="381600" tIns="0" rIns="381600" bIns="0" rtlCol="0" anchor="ctr"/>
           <a:lstStyle/>
           <a:p>
             <a:pPr algn="l"/>
@@ -5715,7 +5792,7 @@
           <a:noFill/>
         </p:spPr>
         <p:txBody>
-          <a:bodyPr wrap="square" tIns="0" bIns="0" lIns="0" rIns="0">
+          <a:bodyPr wrap="square" lIns="0" tIns="0" rIns="0" bIns="0">
             <a:spAutoFit/>
           </a:bodyPr>
           <a:lstStyle/>
@@ -5750,7 +5827,7 @@
           <a:noFill/>
         </p:spPr>
         <p:txBody>
-          <a:bodyPr wrap="square" tIns="0" bIns="0" lIns="0" rIns="0">
+          <a:bodyPr wrap="square" lIns="0" tIns="0" rIns="0" bIns="0">
             <a:spAutoFit/>
           </a:bodyPr>
           <a:lstStyle/>
@@ -5785,7 +5862,7 @@
           <a:noFill/>
         </p:spPr>
         <p:txBody>
-          <a:bodyPr wrap="square" tIns="0" bIns="0" lIns="0" rIns="0">
+          <a:bodyPr wrap="square" lIns="0" tIns="0" rIns="0" bIns="0">
             <a:spAutoFit/>
           </a:bodyPr>
           <a:lstStyle/>
@@ -5820,7 +5897,7 @@
           <a:noFill/>
         </p:spPr>
         <p:txBody>
-          <a:bodyPr wrap="square" tIns="0" bIns="0" lIns="0" rIns="0">
+          <a:bodyPr wrap="square" lIns="0" tIns="0" rIns="0" bIns="0">
             <a:spAutoFit/>
           </a:bodyPr>
           <a:lstStyle/>
@@ -5855,7 +5932,7 @@
           <a:noFill/>
         </p:spPr>
         <p:txBody>
-          <a:bodyPr wrap="square" tIns="0" bIns="0" lIns="0" rIns="0">
+          <a:bodyPr wrap="square" lIns="0" tIns="0" rIns="0" bIns="0">
             <a:spAutoFit/>
           </a:bodyPr>
           <a:lstStyle/>
@@ -5915,6 +5992,7 @@
           <a:lstStyle/>
           <a:p>
             <a:pPr algn="ctr"/>
+            <a:endParaRPr/>
           </a:p>
         </p:txBody>
       </p:sp>
@@ -5935,7 +6013,7 @@
           <a:noFill/>
         </p:spPr>
         <p:txBody>
-          <a:bodyPr wrap="square" tIns="0" bIns="0" lIns="0" rIns="0">
+          <a:bodyPr wrap="square" lIns="0" tIns="0" rIns="0" bIns="0">
             <a:spAutoFit/>
           </a:bodyPr>
           <a:lstStyle/>
@@ -5965,7 +6043,7 @@
 </file>
 
 <file path=ppt/slides/slide19.xml><?xml version="1.0" encoding="utf-8"?>
-<p:sld xmlns:a="http://schemas.openxmlformats.org/drawingml/2006/main" xmlns:p="http://schemas.openxmlformats.org/presentationml/2006/main" xmlns:r="http://schemas.openxmlformats.org/officeDocument/2006/relationships">
+<p:sld xmlns:a="http://schemas.openxmlformats.org/drawingml/2006/main" xmlns:r="http://schemas.openxmlformats.org/officeDocument/2006/relationships" xmlns:p="http://schemas.openxmlformats.org/presentationml/2006/main">
   <p:cSld>
     <p:spTree>
       <p:nvGrpSpPr>
@@ -5973,7 +6051,14 @@
         <p:cNvGrpSpPr/>
         <p:nvPr/>
       </p:nvGrpSpPr>
-      <p:grpSpPr/>
+      <p:grpSpPr>
+        <a:xfrm>
+          <a:off x="0" y="0"/>
+          <a:ext cx="0" cy="0"/>
+          <a:chOff x="0" y="0"/>
+          <a:chExt cx="0" cy="0"/>
+        </a:xfrm>
+      </p:grpSpPr>
       <p:sp>
         <p:nvSpPr>
           <p:cNvPr id="2" name="Rectangle 1"/>
@@ -6014,6 +6099,7 @@
           <a:lstStyle/>
           <a:p>
             <a:pPr algn="ctr"/>
+            <a:endParaRPr/>
           </a:p>
         </p:txBody>
       </p:sp>
@@ -6034,7 +6120,7 @@
           <a:noFill/>
         </p:spPr>
         <p:txBody>
-          <a:bodyPr wrap="square" tIns="0" bIns="0" lIns="0" rIns="0">
+          <a:bodyPr wrap="square" lIns="0" tIns="0" rIns="0" bIns="0">
             <a:spAutoFit/>
           </a:bodyPr>
           <a:lstStyle/>
@@ -6092,6 +6178,7 @@
           <a:lstStyle/>
           <a:p>
             <a:pPr algn="ctr"/>
+            <a:endParaRPr/>
           </a:p>
         </p:txBody>
       </p:sp>
@@ -6135,6 +6222,7 @@
           <a:lstStyle/>
           <a:p>
             <a:pPr algn="ctr"/>
+            <a:endParaRPr/>
           </a:p>
         </p:txBody>
       </p:sp>
@@ -6155,7 +6243,7 @@
           <a:noFill/>
         </p:spPr>
         <p:txBody>
-          <a:bodyPr wrap="square" tIns="0" bIns="0" lIns="0" rIns="0">
+          <a:bodyPr wrap="square" lIns="0" tIns="0" rIns="0" bIns="0">
             <a:spAutoFit/>
           </a:bodyPr>
           <a:lstStyle/>
@@ -6213,6 +6301,7 @@
           <a:lstStyle/>
           <a:p>
             <a:pPr algn="ctr"/>
+            <a:endParaRPr/>
           </a:p>
         </p:txBody>
       </p:sp>
@@ -6233,7 +6322,7 @@
           <a:noFill/>
         </p:spPr>
         <p:txBody>
-          <a:bodyPr wrap="square" tIns="0" bIns="0" lIns="0" rIns="0">
+          <a:bodyPr wrap="square" lIns="0" tIns="0" rIns="0" bIns="0">
             <a:spAutoFit/>
           </a:bodyPr>
           <a:lstStyle/>
@@ -6268,7 +6357,7 @@
           <a:noFill/>
         </p:spPr>
         <p:txBody>
-          <a:bodyPr wrap="square" tIns="0" bIns="0" lIns="0" rIns="0">
+          <a:bodyPr wrap="square" lIns="0" tIns="0" rIns="0" bIns="0">
             <a:spAutoFit/>
           </a:bodyPr>
           <a:lstStyle/>
@@ -6326,6 +6415,7 @@
           <a:lstStyle/>
           <a:p>
             <a:pPr algn="ctr"/>
+            <a:endParaRPr/>
           </a:p>
         </p:txBody>
       </p:sp>
@@ -6346,7 +6436,7 @@
           <a:noFill/>
         </p:spPr>
         <p:txBody>
-          <a:bodyPr wrap="square" tIns="0" bIns="0" lIns="0" rIns="0">
+          <a:bodyPr wrap="square" lIns="0" tIns="0" rIns="0" bIns="0">
             <a:spAutoFit/>
           </a:bodyPr>
           <a:lstStyle/>
@@ -6404,6 +6494,7 @@
           <a:lstStyle/>
           <a:p>
             <a:pPr algn="ctr"/>
+            <a:endParaRPr/>
           </a:p>
         </p:txBody>
       </p:sp>
@@ -6424,7 +6515,7 @@
           <a:noFill/>
         </p:spPr>
         <p:txBody>
-          <a:bodyPr wrap="square" tIns="0" bIns="0" lIns="0" rIns="0">
+          <a:bodyPr wrap="square" lIns="0" tIns="0" rIns="0" bIns="0">
             <a:spAutoFit/>
           </a:bodyPr>
           <a:lstStyle/>
@@ -6459,7 +6550,7 @@
           <a:noFill/>
         </p:spPr>
         <p:txBody>
-          <a:bodyPr wrap="square" tIns="0" bIns="0" lIns="0" rIns="0">
+          <a:bodyPr wrap="square" lIns="0" tIns="0" rIns="0" bIns="0">
             <a:spAutoFit/>
           </a:bodyPr>
           <a:lstStyle/>
@@ -6517,6 +6608,7 @@
           <a:lstStyle/>
           <a:p>
             <a:pPr algn="ctr"/>
+            <a:endParaRPr/>
           </a:p>
         </p:txBody>
       </p:sp>
@@ -6537,7 +6629,7 @@
           <a:noFill/>
         </p:spPr>
         <p:txBody>
-          <a:bodyPr wrap="square" tIns="0" bIns="0" lIns="0" rIns="0">
+          <a:bodyPr wrap="square" lIns="0" tIns="0" rIns="0" bIns="0">
             <a:spAutoFit/>
           </a:bodyPr>
           <a:lstStyle/>
@@ -6595,6 +6687,7 @@
           <a:lstStyle/>
           <a:p>
             <a:pPr algn="ctr"/>
+            <a:endParaRPr/>
           </a:p>
         </p:txBody>
       </p:sp>
@@ -6615,7 +6708,7 @@
           <a:noFill/>
         </p:spPr>
         <p:txBody>
-          <a:bodyPr wrap="square" tIns="0" bIns="0" lIns="0" rIns="0">
+          <a:bodyPr wrap="square" lIns="0" tIns="0" rIns="0" bIns="0">
             <a:spAutoFit/>
           </a:bodyPr>
           <a:lstStyle/>
@@ -6650,7 +6743,7 @@
           <a:noFill/>
         </p:spPr>
         <p:txBody>
-          <a:bodyPr wrap="square" tIns="0" bIns="0" lIns="0" rIns="0">
+          <a:bodyPr wrap="square" lIns="0" tIns="0" rIns="0" bIns="0">
             <a:spAutoFit/>
           </a:bodyPr>
           <a:lstStyle/>
@@ -6685,7 +6778,7 @@
           <a:noFill/>
         </p:spPr>
         <p:txBody>
-          <a:bodyPr wrap="square" tIns="0" bIns="0" lIns="0" rIns="0">
+          <a:bodyPr wrap="square" lIns="0" tIns="0" rIns="0" bIns="0">
             <a:spAutoFit/>
           </a:bodyPr>
           <a:lstStyle/>
@@ -6712,7 +6805,7 @@
 </file>
 
 <file path=ppt/slides/slide2.xml><?xml version="1.0" encoding="utf-8"?>
-<p:sld xmlns:a="http://schemas.openxmlformats.org/drawingml/2006/main" xmlns:p="http://schemas.openxmlformats.org/presentationml/2006/main" xmlns:r="http://schemas.openxmlformats.org/officeDocument/2006/relationships">
+<p:sld xmlns:a="http://schemas.openxmlformats.org/drawingml/2006/main" xmlns:r="http://schemas.openxmlformats.org/officeDocument/2006/relationships" xmlns:p="http://schemas.openxmlformats.org/presentationml/2006/main">
   <p:cSld>
     <p:spTree>
       <p:nvGrpSpPr>
@@ -6720,7 +6813,14 @@
         <p:cNvGrpSpPr/>
         <p:nvPr/>
       </p:nvGrpSpPr>
-      <p:grpSpPr/>
+      <p:grpSpPr>
+        <a:xfrm>
+          <a:off x="0" y="0"/>
+          <a:ext cx="0" cy="0"/>
+          <a:chOff x="0" y="0"/>
+          <a:chExt cx="0" cy="0"/>
+        </a:xfrm>
+      </p:grpSpPr>
       <p:sp>
         <p:nvSpPr>
           <p:cNvPr id="2" name="Rectangle 1"/>
@@ -6761,6 +6861,7 @@
           <a:lstStyle/>
           <a:p>
             <a:pPr algn="ctr"/>
+            <a:endParaRPr/>
           </a:p>
         </p:txBody>
       </p:sp>
@@ -6800,7 +6901,7 @@
           </a:fontRef>
         </p:style>
         <p:txBody>
-          <a:bodyPr rtlCol="0" anchor="ctr" wrap="none" tIns="0" bIns="0" lIns="381600" rIns="381600"/>
+          <a:bodyPr wrap="none" lIns="381600" tIns="0" rIns="381600" bIns="0" rtlCol="0" anchor="ctr"/>
           <a:lstStyle/>
           <a:p>
             <a:pPr algn="l"/>
@@ -6833,7 +6934,7 @@
           <a:noFill/>
         </p:spPr>
         <p:txBody>
-          <a:bodyPr wrap="square" tIns="0" bIns="0" lIns="0" rIns="0">
+          <a:bodyPr wrap="square" lIns="0" tIns="0" rIns="0" bIns="0">
             <a:spAutoFit/>
           </a:bodyPr>
           <a:lstStyle/>
@@ -6891,6 +6992,7 @@
           <a:lstStyle/>
           <a:p>
             <a:pPr algn="ctr"/>
+            <a:endParaRPr/>
           </a:p>
         </p:txBody>
       </p:sp>
@@ -6911,7 +7013,7 @@
           <a:noFill/>
         </p:spPr>
         <p:txBody>
-          <a:bodyPr wrap="square" tIns="0" bIns="0" lIns="0" rIns="0">
+          <a:bodyPr wrap="square" lIns="0" tIns="0" rIns="0" bIns="0">
             <a:spAutoFit/>
           </a:bodyPr>
           <a:lstStyle/>
@@ -6946,7 +7048,7 @@
           <a:noFill/>
         </p:spPr>
         <p:txBody>
-          <a:bodyPr wrap="square" tIns="0" bIns="0" lIns="0" rIns="0">
+          <a:bodyPr wrap="square" lIns="0" tIns="0" rIns="0" bIns="0">
             <a:spAutoFit/>
           </a:bodyPr>
           <a:lstStyle/>
@@ -7004,6 +7106,7 @@
           <a:lstStyle/>
           <a:p>
             <a:pPr algn="ctr"/>
+            <a:endParaRPr/>
           </a:p>
         </p:txBody>
       </p:sp>
@@ -7024,7 +7127,7 @@
           <a:noFill/>
         </p:spPr>
         <p:txBody>
-          <a:bodyPr wrap="square" tIns="0" bIns="0" lIns="0" rIns="0">
+          <a:bodyPr wrap="square" lIns="0" tIns="0" rIns="0" bIns="0">
             <a:spAutoFit/>
           </a:bodyPr>
           <a:lstStyle/>
@@ -7059,7 +7162,7 @@
           <a:noFill/>
         </p:spPr>
         <p:txBody>
-          <a:bodyPr wrap="square" tIns="0" bIns="0" lIns="0" rIns="0">
+          <a:bodyPr wrap="square" lIns="0" tIns="0" rIns="0" bIns="0">
             <a:spAutoFit/>
           </a:bodyPr>
           <a:lstStyle/>
@@ -7117,6 +7220,7 @@
           <a:lstStyle/>
           <a:p>
             <a:pPr algn="ctr"/>
+            <a:endParaRPr/>
           </a:p>
         </p:txBody>
       </p:sp>
@@ -7137,7 +7241,7 @@
           <a:noFill/>
         </p:spPr>
         <p:txBody>
-          <a:bodyPr wrap="square" tIns="0" bIns="0" lIns="0" rIns="0">
+          <a:bodyPr wrap="square" lIns="0" tIns="0" rIns="0" bIns="0">
             <a:spAutoFit/>
           </a:bodyPr>
           <a:lstStyle/>
@@ -7172,7 +7276,7 @@
           <a:noFill/>
         </p:spPr>
         <p:txBody>
-          <a:bodyPr wrap="square" tIns="0" bIns="0" lIns="0" rIns="0">
+          <a:bodyPr wrap="square" lIns="0" tIns="0" rIns="0" bIns="0">
             <a:spAutoFit/>
           </a:bodyPr>
           <a:lstStyle/>
@@ -7230,6 +7334,7 @@
           <a:lstStyle/>
           <a:p>
             <a:pPr algn="ctr"/>
+            <a:endParaRPr/>
           </a:p>
         </p:txBody>
       </p:sp>
@@ -7250,7 +7355,7 @@
           <a:noFill/>
         </p:spPr>
         <p:txBody>
-          <a:bodyPr wrap="square" tIns="0" bIns="0" lIns="0" rIns="0">
+          <a:bodyPr wrap="square" lIns="0" tIns="0" rIns="0" bIns="0">
             <a:spAutoFit/>
           </a:bodyPr>
           <a:lstStyle/>
@@ -7285,7 +7390,7 @@
           <a:noFill/>
         </p:spPr>
         <p:txBody>
-          <a:bodyPr wrap="square" tIns="0" bIns="0" lIns="0" rIns="0">
+          <a:bodyPr wrap="square" lIns="0" tIns="0" rIns="0" bIns="0">
             <a:spAutoFit/>
           </a:bodyPr>
           <a:lstStyle/>
@@ -7343,6 +7448,7 @@
           <a:lstStyle/>
           <a:p>
             <a:pPr algn="ctr"/>
+            <a:endParaRPr/>
           </a:p>
         </p:txBody>
       </p:sp>
@@ -7363,7 +7469,7 @@
           <a:noFill/>
         </p:spPr>
         <p:txBody>
-          <a:bodyPr wrap="square" tIns="0" bIns="0" lIns="0" rIns="0">
+          <a:bodyPr wrap="square" lIns="0" tIns="0" rIns="0" bIns="0">
             <a:spAutoFit/>
           </a:bodyPr>
           <a:lstStyle/>
@@ -7398,7 +7504,7 @@
           <a:noFill/>
         </p:spPr>
         <p:txBody>
-          <a:bodyPr wrap="square" tIns="0" bIns="0" lIns="0" rIns="0">
+          <a:bodyPr wrap="square" lIns="0" tIns="0" rIns="0" bIns="0">
             <a:spAutoFit/>
           </a:bodyPr>
           <a:lstStyle/>
@@ -7456,6 +7562,7 @@
           <a:lstStyle/>
           <a:p>
             <a:pPr algn="ctr"/>
+            <a:endParaRPr/>
           </a:p>
         </p:txBody>
       </p:sp>
@@ -7476,7 +7583,7 @@
           <a:noFill/>
         </p:spPr>
         <p:txBody>
-          <a:bodyPr wrap="square" tIns="0" bIns="0" lIns="0" rIns="0">
+          <a:bodyPr wrap="square" lIns="0" tIns="0" rIns="0" bIns="0">
             <a:spAutoFit/>
           </a:bodyPr>
           <a:lstStyle/>
@@ -7503,7 +7610,7 @@
 </file>
 
 <file path=ppt/slides/slide3.xml><?xml version="1.0" encoding="utf-8"?>
-<p:sld xmlns:a="http://schemas.openxmlformats.org/drawingml/2006/main" xmlns:p="http://schemas.openxmlformats.org/presentationml/2006/main" xmlns:r="http://schemas.openxmlformats.org/officeDocument/2006/relationships">
+<p:sld xmlns:a="http://schemas.openxmlformats.org/drawingml/2006/main" xmlns:r="http://schemas.openxmlformats.org/officeDocument/2006/relationships" xmlns:p="http://schemas.openxmlformats.org/presentationml/2006/main">
   <p:cSld>
     <p:spTree>
       <p:nvGrpSpPr>
@@ -7511,7 +7618,14 @@
         <p:cNvGrpSpPr/>
         <p:nvPr/>
       </p:nvGrpSpPr>
-      <p:grpSpPr/>
+      <p:grpSpPr>
+        <a:xfrm>
+          <a:off x="0" y="0"/>
+          <a:ext cx="0" cy="0"/>
+          <a:chOff x="0" y="0"/>
+          <a:chExt cx="0" cy="0"/>
+        </a:xfrm>
+      </p:grpSpPr>
       <p:sp>
         <p:nvSpPr>
           <p:cNvPr id="2" name="Rectangle 1"/>
@@ -7552,6 +7666,7 @@
           <a:lstStyle/>
           <a:p>
             <a:pPr algn="ctr"/>
+            <a:endParaRPr/>
           </a:p>
         </p:txBody>
       </p:sp>
@@ -7591,7 +7706,7 @@
           </a:fontRef>
         </p:style>
         <p:txBody>
-          <a:bodyPr rtlCol="0" anchor="ctr" wrap="none" tIns="0" bIns="0" lIns="381600" rIns="381600"/>
+          <a:bodyPr wrap="none" lIns="381600" tIns="0" rIns="381600" bIns="0" rtlCol="0" anchor="ctr"/>
           <a:lstStyle/>
           <a:p>
             <a:pPr algn="l"/>
@@ -7648,6 +7763,7 @@
           <a:lstStyle/>
           <a:p>
             <a:pPr algn="ctr"/>
+            <a:endParaRPr/>
           </a:p>
         </p:txBody>
       </p:sp>
@@ -7691,6 +7807,7 @@
           <a:lstStyle/>
           <a:p>
             <a:pPr algn="ctr"/>
+            <a:endParaRPr/>
           </a:p>
         </p:txBody>
       </p:sp>
@@ -7711,7 +7828,7 @@
           <a:noFill/>
         </p:spPr>
         <p:txBody>
-          <a:bodyPr wrap="square" tIns="0" bIns="0" lIns="0" rIns="0">
+          <a:bodyPr wrap="square" lIns="0" tIns="0" rIns="0" bIns="0">
             <a:spAutoFit/>
           </a:bodyPr>
           <a:lstStyle/>
@@ -7770,6 +7887,7 @@
           <a:lstStyle/>
           <a:p>
             <a:pPr algn="ctr"/>
+            <a:endParaRPr/>
           </a:p>
         </p:txBody>
       </p:sp>
@@ -7790,7 +7908,7 @@
           <a:noFill/>
         </p:spPr>
         <p:txBody>
-          <a:bodyPr wrap="square" tIns="0" bIns="0" lIns="0" rIns="0">
+          <a:bodyPr wrap="square" lIns="0" tIns="0" rIns="0" bIns="0">
             <a:spAutoFit/>
           </a:bodyPr>
           <a:lstStyle/>
@@ -7849,6 +7967,7 @@
           <a:lstStyle/>
           <a:p>
             <a:pPr algn="ctr"/>
+            <a:endParaRPr/>
           </a:p>
         </p:txBody>
       </p:sp>
@@ -7869,7 +7988,7 @@
           <a:noFill/>
         </p:spPr>
         <p:txBody>
-          <a:bodyPr wrap="square" tIns="0" bIns="0" lIns="0" rIns="0">
+          <a:bodyPr wrap="square" lIns="0" tIns="0" rIns="0" bIns="0">
             <a:spAutoFit/>
           </a:bodyPr>
           <a:lstStyle/>
@@ -7928,6 +8047,7 @@
           <a:lstStyle/>
           <a:p>
             <a:pPr algn="ctr"/>
+            <a:endParaRPr/>
           </a:p>
         </p:txBody>
       </p:sp>
@@ -7948,7 +8068,7 @@
           <a:noFill/>
         </p:spPr>
         <p:txBody>
-          <a:bodyPr wrap="square" tIns="0" bIns="0" lIns="0" rIns="0">
+          <a:bodyPr wrap="square" lIns="0" tIns="0" rIns="0" bIns="0">
             <a:spAutoFit/>
           </a:bodyPr>
           <a:lstStyle/>
@@ -8007,6 +8127,7 @@
           <a:lstStyle/>
           <a:p>
             <a:pPr algn="ctr"/>
+            <a:endParaRPr/>
           </a:p>
         </p:txBody>
       </p:sp>
@@ -8027,7 +8148,7 @@
           <a:noFill/>
         </p:spPr>
         <p:txBody>
-          <a:bodyPr wrap="square" tIns="0" bIns="0" lIns="0" rIns="0">
+          <a:bodyPr wrap="square" lIns="0" tIns="0" rIns="0" bIns="0">
             <a:spAutoFit/>
           </a:bodyPr>
           <a:lstStyle/>
@@ -8086,6 +8207,7 @@
           <a:lstStyle/>
           <a:p>
             <a:pPr algn="ctr"/>
+            <a:endParaRPr/>
           </a:p>
         </p:txBody>
       </p:sp>
@@ -8106,7 +8228,7 @@
           <a:noFill/>
         </p:spPr>
         <p:txBody>
-          <a:bodyPr wrap="square" tIns="0" bIns="0" lIns="0" rIns="0">
+          <a:bodyPr wrap="square" lIns="0" tIns="0" rIns="0" bIns="0">
             <a:spAutoFit/>
           </a:bodyPr>
           <a:lstStyle/>
@@ -8165,6 +8287,7 @@
           <a:lstStyle/>
           <a:p>
             <a:pPr algn="ctr"/>
+            <a:endParaRPr/>
           </a:p>
         </p:txBody>
       </p:sp>
@@ -8185,7 +8308,7 @@
           <a:noFill/>
         </p:spPr>
         <p:txBody>
-          <a:bodyPr wrap="square" tIns="0" bIns="0" lIns="0" rIns="0">
+          <a:bodyPr wrap="square" lIns="0" tIns="0" rIns="0" bIns="0">
             <a:spAutoFit/>
           </a:bodyPr>
           <a:lstStyle/>
@@ -8221,7 +8344,7 @@
           <a:noFill/>
         </p:spPr>
         <p:txBody>
-          <a:bodyPr wrap="square" tIns="0" bIns="0" lIns="0" rIns="0">
+          <a:bodyPr wrap="square" lIns="0" tIns="0" rIns="0" bIns="0">
             <a:spAutoFit/>
           </a:bodyPr>
           <a:lstStyle/>
@@ -8248,7 +8371,7 @@
 </file>
 
 <file path=ppt/slides/slide4.xml><?xml version="1.0" encoding="utf-8"?>
-<p:sld xmlns:a="http://schemas.openxmlformats.org/drawingml/2006/main" xmlns:p="http://schemas.openxmlformats.org/presentationml/2006/main" xmlns:r="http://schemas.openxmlformats.org/officeDocument/2006/relationships">
+<p:sld xmlns:a="http://schemas.openxmlformats.org/drawingml/2006/main" xmlns:r="http://schemas.openxmlformats.org/officeDocument/2006/relationships" xmlns:p="http://schemas.openxmlformats.org/presentationml/2006/main">
   <p:cSld>
     <p:spTree>
       <p:nvGrpSpPr>
@@ -8256,7 +8379,14 @@
         <p:cNvGrpSpPr/>
         <p:nvPr/>
       </p:nvGrpSpPr>
-      <p:grpSpPr/>
+      <p:grpSpPr>
+        <a:xfrm>
+          <a:off x="0" y="0"/>
+          <a:ext cx="0" cy="0"/>
+          <a:chOff x="0" y="0"/>
+          <a:chExt cx="0" cy="0"/>
+        </a:xfrm>
+      </p:grpSpPr>
       <p:sp>
         <p:nvSpPr>
           <p:cNvPr id="2" name="Rectangle 1"/>
@@ -8297,6 +8427,7 @@
           <a:lstStyle/>
           <a:p>
             <a:pPr algn="ctr"/>
+            <a:endParaRPr/>
           </a:p>
         </p:txBody>
       </p:sp>
@@ -8317,7 +8448,7 @@
           <a:noFill/>
         </p:spPr>
         <p:txBody>
-          <a:bodyPr wrap="square" tIns="0" bIns="0" lIns="0" rIns="0">
+          <a:bodyPr wrap="square" lIns="0" tIns="0" rIns="0" bIns="0">
             <a:spAutoFit/>
           </a:bodyPr>
           <a:lstStyle/>
@@ -8375,6 +8506,7 @@
           <a:lstStyle/>
           <a:p>
             <a:pPr algn="ctr"/>
+            <a:endParaRPr/>
           </a:p>
         </p:txBody>
       </p:sp>
@@ -8395,7 +8527,7 @@
           <a:noFill/>
         </p:spPr>
         <p:txBody>
-          <a:bodyPr wrap="square" tIns="0" bIns="0" lIns="0" rIns="0">
+          <a:bodyPr wrap="square" lIns="0" tIns="0" rIns="0" bIns="0">
             <a:spAutoFit/>
           </a:bodyPr>
           <a:lstStyle/>
@@ -8422,7 +8554,7 @@
 </file>
 
 <file path=ppt/slides/slide5.xml><?xml version="1.0" encoding="utf-8"?>
-<p:sld xmlns:a="http://schemas.openxmlformats.org/drawingml/2006/main" xmlns:p="http://schemas.openxmlformats.org/presentationml/2006/main" xmlns:r="http://schemas.openxmlformats.org/officeDocument/2006/relationships">
+<p:sld xmlns:a="http://schemas.openxmlformats.org/drawingml/2006/main" xmlns:r="http://schemas.openxmlformats.org/officeDocument/2006/relationships" xmlns:p="http://schemas.openxmlformats.org/presentationml/2006/main">
   <p:cSld>
     <p:spTree>
       <p:nvGrpSpPr>
@@ -8430,7 +8562,14 @@
         <p:cNvGrpSpPr/>
         <p:nvPr/>
       </p:nvGrpSpPr>
-      <p:grpSpPr/>
+      <p:grpSpPr>
+        <a:xfrm>
+          <a:off x="0" y="0"/>
+          <a:ext cx="0" cy="0"/>
+          <a:chOff x="0" y="0"/>
+          <a:chExt cx="0" cy="0"/>
+        </a:xfrm>
+      </p:grpSpPr>
       <p:sp>
         <p:nvSpPr>
           <p:cNvPr id="2" name="Rectangle 1"/>
@@ -8471,6 +8610,7 @@
           <a:lstStyle/>
           <a:p>
             <a:pPr algn="ctr"/>
+            <a:endParaRPr/>
           </a:p>
         </p:txBody>
       </p:sp>
@@ -8510,7 +8650,7 @@
           </a:fontRef>
         </p:style>
         <p:txBody>
-          <a:bodyPr rtlCol="0" anchor="ctr" wrap="none" tIns="0" bIns="0" lIns="381600" rIns="381600"/>
+          <a:bodyPr wrap="none" lIns="381600" tIns="0" rIns="381600" bIns="0" rtlCol="0" anchor="ctr"/>
           <a:lstStyle/>
           <a:p>
             <a:pPr algn="l"/>
@@ -8566,6 +8706,7 @@
           <a:lstStyle/>
           <a:p>
             <a:pPr algn="ctr"/>
+            <a:endParaRPr/>
           </a:p>
         </p:txBody>
       </p:sp>
@@ -8578,7 +8719,7 @@
         <p:spPr>
           <a:xfrm>
             <a:off x="323999" y="705599"/>
-            <a:ext cx="11509201" cy="5144401"/>
+            <a:ext cx="11509201" cy="3693319"/>
           </a:xfrm>
           <a:prstGeom prst="rect">
             <a:avLst/>
@@ -8586,25 +8727,460 @@
           <a:noFill/>
         </p:spPr>
         <p:txBody>
-          <a:bodyPr wrap="square" tIns="0" bIns="0" lIns="0" rIns="0">
+          <a:bodyPr wrap="square" lIns="0" tIns="0" rIns="0" bIns="0">
             <a:spAutoFit/>
           </a:bodyPr>
           <a:lstStyle/>
           <a:p>
-            <a:pPr algn="l"/>
-            <a:r>
-              <a:rPr sz="1700" b="0" i="0">
+            <a:pPr marL="342900" indent="-342900" algn="l">
+              <a:buFont typeface="Arial" panose="020B0604020202020204" pitchFamily="34" charset="0"/>
+              <a:buChar char="•"/>
+            </a:pPr>
+            <a:r>
+              <a:rPr sz="2400" b="0" i="0" dirty="0">
                 <a:solidFill>
                   <a:srgbClr val="000000"/>
                 </a:solidFill>
                 <a:latin typeface="Montserrat"/>
               </a:rPr>
-              <a:t>• Una sub-interface (virtuale) suddivide logicamente una porta fisica con tag VLAN 802.1Q
-• Sintassi IOS: interface eth0/0.&lt;vlan&gt;  →  encapsulation dot1Q &lt;vlan&gt;
-• L'interfaccia fisica padre deve avere no ip address + no shutdown (nessuna configurazione IP)
-• Il numero sub-interface coincide per convenzione con il numero VLAN (leggibilità)
-• Ogni sub-interface ha il proprio indirizzo IP e partecipa independentemente ai protocolli
-• In ambiente IOU: tutta la connettività inter-router avviene via sub-interface (no link fisici diretti)</a:t>
+              <a:t>Una sub-interface (</a:t>
+            </a:r>
+            <a:r>
+              <a:rPr sz="2400" b="0" i="0" dirty="0" err="1">
+                <a:solidFill>
+                  <a:srgbClr val="000000"/>
+                </a:solidFill>
+                <a:latin typeface="Montserrat"/>
+              </a:rPr>
+              <a:t>virtuale</a:t>
+            </a:r>
+            <a:r>
+              <a:rPr sz="2400" b="0" i="0" dirty="0">
+                <a:solidFill>
+                  <a:srgbClr val="000000"/>
+                </a:solidFill>
+                <a:latin typeface="Montserrat"/>
+              </a:rPr>
+              <a:t>) </a:t>
+            </a:r>
+            <a:r>
+              <a:rPr sz="2400" b="0" i="0" dirty="0" err="1">
+                <a:solidFill>
+                  <a:srgbClr val="000000"/>
+                </a:solidFill>
+                <a:latin typeface="Montserrat"/>
+              </a:rPr>
+              <a:t>suddivide</a:t>
+            </a:r>
+            <a:r>
+              <a:rPr sz="2400" b="0" i="0" dirty="0">
+                <a:solidFill>
+                  <a:srgbClr val="000000"/>
+                </a:solidFill>
+                <a:latin typeface="Montserrat"/>
+              </a:rPr>
+              <a:t> </a:t>
+            </a:r>
+            <a:r>
+              <a:rPr sz="2400" b="0" i="0" dirty="0" err="1">
+                <a:solidFill>
+                  <a:srgbClr val="000000"/>
+                </a:solidFill>
+                <a:latin typeface="Montserrat"/>
+              </a:rPr>
+              <a:t>logicamente</a:t>
+            </a:r>
+            <a:r>
+              <a:rPr sz="2400" b="0" i="0" dirty="0">
+                <a:solidFill>
+                  <a:srgbClr val="000000"/>
+                </a:solidFill>
+                <a:latin typeface="Montserrat"/>
+              </a:rPr>
+              <a:t> </a:t>
+            </a:r>
+            <a:r>
+              <a:rPr sz="2400" b="0" i="0" dirty="0" err="1">
+                <a:solidFill>
+                  <a:srgbClr val="000000"/>
+                </a:solidFill>
+                <a:latin typeface="Montserrat"/>
+              </a:rPr>
+              <a:t>una</a:t>
+            </a:r>
+            <a:r>
+              <a:rPr sz="2400" b="0" i="0" dirty="0">
+                <a:solidFill>
+                  <a:srgbClr val="000000"/>
+                </a:solidFill>
+                <a:latin typeface="Montserrat"/>
+              </a:rPr>
+              <a:t> porta </a:t>
+            </a:r>
+            <a:r>
+              <a:rPr sz="2400" b="0" i="0" dirty="0" err="1">
+                <a:solidFill>
+                  <a:srgbClr val="000000"/>
+                </a:solidFill>
+                <a:latin typeface="Montserrat"/>
+              </a:rPr>
+              <a:t>fisica</a:t>
+            </a:r>
+            <a:r>
+              <a:rPr sz="2400" b="0" i="0" dirty="0">
+                <a:solidFill>
+                  <a:srgbClr val="000000"/>
+                </a:solidFill>
+                <a:latin typeface="Montserrat"/>
+              </a:rPr>
+              <a:t> con tag VLAN 802.1Q
+</a:t>
+            </a:r>
+            <a:r>
+              <a:rPr sz="2400" b="0" i="0" dirty="0" err="1">
+                <a:solidFill>
+                  <a:srgbClr val="000000"/>
+                </a:solidFill>
+                <a:latin typeface="Montserrat"/>
+              </a:rPr>
+              <a:t>Sintassi</a:t>
+            </a:r>
+            <a:r>
+              <a:rPr sz="2400" b="0" i="0" dirty="0">
+                <a:solidFill>
+                  <a:srgbClr val="000000"/>
+                </a:solidFill>
+                <a:latin typeface="Montserrat"/>
+              </a:rPr>
+              <a:t> IOS: interface eth0/0.&lt;</a:t>
+            </a:r>
+            <a:r>
+              <a:rPr sz="2400" b="0" i="0" dirty="0" err="1">
+                <a:solidFill>
+                  <a:srgbClr val="000000"/>
+                </a:solidFill>
+                <a:latin typeface="Montserrat"/>
+              </a:rPr>
+              <a:t>vlan</a:t>
+            </a:r>
+            <a:r>
+              <a:rPr sz="2400" b="0" i="0" dirty="0">
+                <a:solidFill>
+                  <a:srgbClr val="000000"/>
+                </a:solidFill>
+                <a:latin typeface="Montserrat"/>
+              </a:rPr>
+              <a:t>&gt;  →  encapsulation dot1Q &lt;</a:t>
+            </a:r>
+            <a:r>
+              <a:rPr sz="2400" b="0" i="0" dirty="0" err="1">
+                <a:solidFill>
+                  <a:srgbClr val="000000"/>
+                </a:solidFill>
+                <a:latin typeface="Montserrat"/>
+              </a:rPr>
+              <a:t>vlan</a:t>
+            </a:r>
+            <a:r>
+              <a:rPr sz="2400" b="0" i="0" dirty="0">
+                <a:solidFill>
+                  <a:srgbClr val="000000"/>
+                </a:solidFill>
+                <a:latin typeface="Montserrat"/>
+              </a:rPr>
+              <a:t>&gt;
+</a:t>
+            </a:r>
+            <a:r>
+              <a:rPr sz="2400" b="0" i="0" dirty="0" err="1">
+                <a:solidFill>
+                  <a:srgbClr val="000000"/>
+                </a:solidFill>
+                <a:latin typeface="Montserrat"/>
+              </a:rPr>
+              <a:t>L'interfaccia</a:t>
+            </a:r>
+            <a:r>
+              <a:rPr sz="2400" b="0" i="0" dirty="0">
+                <a:solidFill>
+                  <a:srgbClr val="000000"/>
+                </a:solidFill>
+                <a:latin typeface="Montserrat"/>
+              </a:rPr>
+              <a:t> </a:t>
+            </a:r>
+            <a:r>
+              <a:rPr sz="2400" b="0" i="0" dirty="0" err="1">
+                <a:solidFill>
+                  <a:srgbClr val="000000"/>
+                </a:solidFill>
+                <a:latin typeface="Montserrat"/>
+              </a:rPr>
+              <a:t>fisica</a:t>
+            </a:r>
+            <a:r>
+              <a:rPr sz="2400" b="0" i="0" dirty="0">
+                <a:solidFill>
+                  <a:srgbClr val="000000"/>
+                </a:solidFill>
+                <a:latin typeface="Montserrat"/>
+              </a:rPr>
+              <a:t> padre </a:t>
+            </a:r>
+            <a:r>
+              <a:rPr sz="2400" b="0" i="0" dirty="0" err="1">
+                <a:solidFill>
+                  <a:srgbClr val="000000"/>
+                </a:solidFill>
+                <a:latin typeface="Montserrat"/>
+              </a:rPr>
+              <a:t>deve</a:t>
+            </a:r>
+            <a:r>
+              <a:rPr sz="2400" b="0" i="0" dirty="0">
+                <a:solidFill>
+                  <a:srgbClr val="000000"/>
+                </a:solidFill>
+                <a:latin typeface="Montserrat"/>
+              </a:rPr>
+              <a:t> </a:t>
+            </a:r>
+            <a:r>
+              <a:rPr sz="2400" b="0" i="0" dirty="0" err="1">
+                <a:solidFill>
+                  <a:srgbClr val="000000"/>
+                </a:solidFill>
+                <a:latin typeface="Montserrat"/>
+              </a:rPr>
+              <a:t>avere</a:t>
+            </a:r>
+            <a:r>
+              <a:rPr sz="2400" b="0" i="0" dirty="0">
+                <a:solidFill>
+                  <a:srgbClr val="000000"/>
+                </a:solidFill>
+                <a:latin typeface="Montserrat"/>
+              </a:rPr>
+              <a:t> no </a:t>
+            </a:r>
+            <a:r>
+              <a:rPr sz="2400" b="0" i="0" dirty="0" err="1">
+                <a:solidFill>
+                  <a:srgbClr val="000000"/>
+                </a:solidFill>
+                <a:latin typeface="Montserrat"/>
+              </a:rPr>
+              <a:t>ip</a:t>
+            </a:r>
+            <a:r>
+              <a:rPr sz="2400" b="0" i="0" dirty="0">
+                <a:solidFill>
+                  <a:srgbClr val="000000"/>
+                </a:solidFill>
+                <a:latin typeface="Montserrat"/>
+              </a:rPr>
+              <a:t> address + no shutdown (</a:t>
+            </a:r>
+            <a:r>
+              <a:rPr sz="2400" b="0" i="0" dirty="0" err="1">
+                <a:solidFill>
+                  <a:srgbClr val="000000"/>
+                </a:solidFill>
+                <a:latin typeface="Montserrat"/>
+              </a:rPr>
+              <a:t>nessuna</a:t>
+            </a:r>
+            <a:r>
+              <a:rPr sz="2400" b="0" i="0" dirty="0">
+                <a:solidFill>
+                  <a:srgbClr val="000000"/>
+                </a:solidFill>
+                <a:latin typeface="Montserrat"/>
+              </a:rPr>
+              <a:t> </a:t>
+            </a:r>
+            <a:r>
+              <a:rPr sz="2400" b="0" i="0" dirty="0" err="1">
+                <a:solidFill>
+                  <a:srgbClr val="000000"/>
+                </a:solidFill>
+                <a:latin typeface="Montserrat"/>
+              </a:rPr>
+              <a:t>configurazione</a:t>
+            </a:r>
+            <a:r>
+              <a:rPr sz="2400" b="0" i="0" dirty="0">
+                <a:solidFill>
+                  <a:srgbClr val="000000"/>
+                </a:solidFill>
+                <a:latin typeface="Montserrat"/>
+              </a:rPr>
+              <a:t> IP)
+Il </a:t>
+            </a:r>
+            <a:r>
+              <a:rPr sz="2400" b="0" i="0" dirty="0" err="1">
+                <a:solidFill>
+                  <a:srgbClr val="000000"/>
+                </a:solidFill>
+                <a:latin typeface="Montserrat"/>
+              </a:rPr>
+              <a:t>numero</a:t>
+            </a:r>
+            <a:r>
+              <a:rPr sz="2400" b="0" i="0" dirty="0">
+                <a:solidFill>
+                  <a:srgbClr val="000000"/>
+                </a:solidFill>
+                <a:latin typeface="Montserrat"/>
+              </a:rPr>
+              <a:t> sub-interface coincide per </a:t>
+            </a:r>
+            <a:r>
+              <a:rPr sz="2400" b="0" i="0" dirty="0" err="1">
+                <a:solidFill>
+                  <a:srgbClr val="000000"/>
+                </a:solidFill>
+                <a:latin typeface="Montserrat"/>
+              </a:rPr>
+              <a:t>convenzione</a:t>
+            </a:r>
+            <a:r>
+              <a:rPr sz="2400" b="0" i="0" dirty="0">
+                <a:solidFill>
+                  <a:srgbClr val="000000"/>
+                </a:solidFill>
+                <a:latin typeface="Montserrat"/>
+              </a:rPr>
+              <a:t> con il </a:t>
+            </a:r>
+            <a:r>
+              <a:rPr sz="2400" b="0" i="0" dirty="0" err="1">
+                <a:solidFill>
+                  <a:srgbClr val="000000"/>
+                </a:solidFill>
+                <a:latin typeface="Montserrat"/>
+              </a:rPr>
+              <a:t>numero</a:t>
+            </a:r>
+            <a:r>
+              <a:rPr sz="2400" b="0" i="0" dirty="0">
+                <a:solidFill>
+                  <a:srgbClr val="000000"/>
+                </a:solidFill>
+                <a:latin typeface="Montserrat"/>
+              </a:rPr>
+              <a:t> VLAN (</a:t>
+            </a:r>
+            <a:r>
+              <a:rPr sz="2400" b="0" i="0" dirty="0" err="1">
+                <a:solidFill>
+                  <a:srgbClr val="000000"/>
+                </a:solidFill>
+                <a:latin typeface="Montserrat"/>
+              </a:rPr>
+              <a:t>leggibilità</a:t>
+            </a:r>
+            <a:r>
+              <a:rPr sz="2400" b="0" i="0" dirty="0">
+                <a:solidFill>
+                  <a:srgbClr val="000000"/>
+                </a:solidFill>
+                <a:latin typeface="Montserrat"/>
+              </a:rPr>
+              <a:t>)
+</a:t>
+            </a:r>
+            <a:r>
+              <a:rPr sz="2400" b="0" i="0" dirty="0" err="1">
+                <a:solidFill>
+                  <a:srgbClr val="000000"/>
+                </a:solidFill>
+                <a:latin typeface="Montserrat"/>
+              </a:rPr>
+              <a:t>Ogni</a:t>
+            </a:r>
+            <a:r>
+              <a:rPr sz="2400" b="0" i="0" dirty="0">
+                <a:solidFill>
+                  <a:srgbClr val="000000"/>
+                </a:solidFill>
+                <a:latin typeface="Montserrat"/>
+              </a:rPr>
+              <a:t> sub-interface ha il proprio </a:t>
+            </a:r>
+            <a:r>
+              <a:rPr sz="2400" b="0" i="0" dirty="0" err="1">
+                <a:solidFill>
+                  <a:srgbClr val="000000"/>
+                </a:solidFill>
+                <a:latin typeface="Montserrat"/>
+              </a:rPr>
+              <a:t>indirizzo</a:t>
+            </a:r>
+            <a:r>
+              <a:rPr sz="2400" b="0" i="0" dirty="0">
+                <a:solidFill>
+                  <a:srgbClr val="000000"/>
+                </a:solidFill>
+                <a:latin typeface="Montserrat"/>
+              </a:rPr>
+              <a:t> IP e </a:t>
+            </a:r>
+            <a:r>
+              <a:rPr sz="2400" b="0" i="0" dirty="0" err="1">
+                <a:solidFill>
+                  <a:srgbClr val="000000"/>
+                </a:solidFill>
+                <a:latin typeface="Montserrat"/>
+              </a:rPr>
+              <a:t>partecipa</a:t>
+            </a:r>
+            <a:r>
+              <a:rPr sz="2400" b="0" i="0" dirty="0">
+                <a:solidFill>
+                  <a:srgbClr val="000000"/>
+                </a:solidFill>
+                <a:latin typeface="Montserrat"/>
+              </a:rPr>
+              <a:t> </a:t>
+            </a:r>
+            <a:r>
+              <a:rPr sz="2400" b="0" i="0" dirty="0" err="1">
+                <a:solidFill>
+                  <a:srgbClr val="000000"/>
+                </a:solidFill>
+                <a:latin typeface="Montserrat"/>
+              </a:rPr>
+              <a:t>independentemente</a:t>
+            </a:r>
+            <a:r>
+              <a:rPr sz="2400" b="0" i="0" dirty="0">
+                <a:solidFill>
+                  <a:srgbClr val="000000"/>
+                </a:solidFill>
+                <a:latin typeface="Montserrat"/>
+              </a:rPr>
+              <a:t> ai </a:t>
+            </a:r>
+            <a:r>
+              <a:rPr sz="2400" b="0" i="0" dirty="0" err="1">
+                <a:solidFill>
+                  <a:srgbClr val="000000"/>
+                </a:solidFill>
+                <a:latin typeface="Montserrat"/>
+              </a:rPr>
+              <a:t>protocolli</a:t>
+            </a:r>
+            <a:r>
+              <a:rPr sz="2400" b="0" i="0" dirty="0">
+                <a:solidFill>
+                  <a:srgbClr val="000000"/>
+                </a:solidFill>
+                <a:latin typeface="Montserrat"/>
+              </a:rPr>
+              <a:t>
+</a:t>
             </a:r>
           </a:p>
         </p:txBody>
@@ -8649,6 +9225,7 @@
           <a:lstStyle/>
           <a:p>
             <a:pPr algn="ctr"/>
+            <a:endParaRPr/>
           </a:p>
         </p:txBody>
       </p:sp>
@@ -8669,7 +9246,7 @@
           <a:noFill/>
         </p:spPr>
         <p:txBody>
-          <a:bodyPr wrap="square" tIns="0" bIns="0" lIns="0" rIns="0">
+          <a:bodyPr wrap="square" lIns="0" tIns="0" rIns="0" bIns="0">
             <a:spAutoFit/>
           </a:bodyPr>
           <a:lstStyle/>
@@ -8696,7 +9273,7 @@
 </file>
 
 <file path=ppt/slides/slide6.xml><?xml version="1.0" encoding="utf-8"?>
-<p:sld xmlns:a="http://schemas.openxmlformats.org/drawingml/2006/main" xmlns:p="http://schemas.openxmlformats.org/presentationml/2006/main" xmlns:r="http://schemas.openxmlformats.org/officeDocument/2006/relationships">
+<p:sld xmlns:a="http://schemas.openxmlformats.org/drawingml/2006/main" xmlns:r="http://schemas.openxmlformats.org/officeDocument/2006/relationships" xmlns:p="http://schemas.openxmlformats.org/presentationml/2006/main">
   <p:cSld>
     <p:spTree>
       <p:nvGrpSpPr>
@@ -8704,7 +9281,14 @@
         <p:cNvGrpSpPr/>
         <p:nvPr/>
       </p:nvGrpSpPr>
-      <p:grpSpPr/>
+      <p:grpSpPr>
+        <a:xfrm>
+          <a:off x="0" y="0"/>
+          <a:ext cx="0" cy="0"/>
+          <a:chOff x="0" y="0"/>
+          <a:chExt cx="0" cy="0"/>
+        </a:xfrm>
+      </p:grpSpPr>
       <p:sp>
         <p:nvSpPr>
           <p:cNvPr id="2" name="Rectangle 1"/>
@@ -8745,6 +9329,7 @@
           <a:lstStyle/>
           <a:p>
             <a:pPr algn="ctr"/>
+            <a:endParaRPr/>
           </a:p>
         </p:txBody>
       </p:sp>
@@ -8784,7 +9369,7 @@
           </a:fontRef>
         </p:style>
         <p:txBody>
-          <a:bodyPr rtlCol="0" anchor="ctr" wrap="none" tIns="0" bIns="0" lIns="381600" rIns="381600"/>
+          <a:bodyPr wrap="none" lIns="381600" tIns="0" rIns="381600" bIns="0" rtlCol="0" anchor="ctr"/>
           <a:lstStyle/>
           <a:p>
             <a:pPr algn="l"/>
@@ -8808,7 +9393,7 @@
         </p:nvSpPr>
         <p:spPr>
           <a:xfrm>
-            <a:off x="360000" y="705600"/>
+            <a:off x="360000" y="721230"/>
             <a:ext cx="11473200" cy="5972400"/>
           </a:xfrm>
           <a:prstGeom prst="rect">
@@ -8838,7 +9423,7 @@
           </a:fontRef>
         </p:style>
         <p:txBody>
-          <a:bodyPr rtlCol="0" anchor="t" wrap="none" tIns="108000" bIns="108000" lIns="144000" rIns="144000"/>
+          <a:bodyPr wrap="none" lIns="144000" tIns="108000" rIns="144000" bIns="108000" rtlCol="0" anchor="t"/>
           <a:lstStyle/>
           <a:p>
             <a:pPr algn="l"/>
@@ -8970,7 +9555,7 @@
         </p:nvSpPr>
         <p:spPr>
           <a:xfrm>
-            <a:off x="396000" y="1893600"/>
+            <a:off x="393630" y="3160800"/>
             <a:ext cx="11401200" cy="216000"/>
           </a:xfrm>
           <a:prstGeom prst="rect">
@@ -9002,6 +9587,7 @@
           <a:lstStyle/>
           <a:p>
             <a:pPr algn="ctr"/>
+            <a:endParaRPr/>
           </a:p>
         </p:txBody>
       </p:sp>
@@ -9045,6 +9631,7 @@
           <a:lstStyle/>
           <a:p>
             <a:pPr algn="ctr"/>
+            <a:endParaRPr/>
           </a:p>
         </p:txBody>
       </p:sp>
@@ -9065,7 +9652,7 @@
           <a:noFill/>
         </p:spPr>
         <p:txBody>
-          <a:bodyPr wrap="square" tIns="0" bIns="0" lIns="0" rIns="0">
+          <a:bodyPr wrap="square" lIns="0" tIns="0" rIns="0" bIns="0">
             <a:spAutoFit/>
           </a:bodyPr>
           <a:lstStyle/>
@@ -9092,7 +9679,7 @@
 </file>
 
 <file path=ppt/slides/slide7.xml><?xml version="1.0" encoding="utf-8"?>
-<p:sld xmlns:a="http://schemas.openxmlformats.org/drawingml/2006/main" xmlns:p="http://schemas.openxmlformats.org/presentationml/2006/main" xmlns:r="http://schemas.openxmlformats.org/officeDocument/2006/relationships">
+<p:sld xmlns:a="http://schemas.openxmlformats.org/drawingml/2006/main" xmlns:r="http://schemas.openxmlformats.org/officeDocument/2006/relationships" xmlns:p="http://schemas.openxmlformats.org/presentationml/2006/main">
   <p:cSld>
     <p:spTree>
       <p:nvGrpSpPr>
@@ -9100,7 +9687,14 @@
         <p:cNvGrpSpPr/>
         <p:nvPr/>
       </p:nvGrpSpPr>
-      <p:grpSpPr/>
+      <p:grpSpPr>
+        <a:xfrm>
+          <a:off x="0" y="0"/>
+          <a:ext cx="0" cy="0"/>
+          <a:chOff x="0" y="0"/>
+          <a:chExt cx="0" cy="0"/>
+        </a:xfrm>
+      </p:grpSpPr>
       <p:sp>
         <p:nvSpPr>
           <p:cNvPr id="2" name="Rectangle 1"/>
@@ -9141,6 +9735,7 @@
           <a:lstStyle/>
           <a:p>
             <a:pPr algn="ctr"/>
+            <a:endParaRPr/>
           </a:p>
         </p:txBody>
       </p:sp>
@@ -9161,7 +9756,7 @@
           <a:noFill/>
         </p:spPr>
         <p:txBody>
-          <a:bodyPr wrap="square" tIns="0" bIns="0" lIns="0" rIns="0">
+          <a:bodyPr wrap="square" lIns="0" tIns="0" rIns="0" bIns="0">
             <a:spAutoFit/>
           </a:bodyPr>
           <a:lstStyle/>
@@ -9219,6 +9814,7 @@
           <a:lstStyle/>
           <a:p>
             <a:pPr algn="ctr"/>
+            <a:endParaRPr/>
           </a:p>
         </p:txBody>
       </p:sp>
@@ -9239,7 +9835,7 @@
           <a:noFill/>
         </p:spPr>
         <p:txBody>
-          <a:bodyPr wrap="square" tIns="0" bIns="0" lIns="0" rIns="0">
+          <a:bodyPr wrap="square" lIns="0" tIns="0" rIns="0" bIns="0">
             <a:spAutoFit/>
           </a:bodyPr>
           <a:lstStyle/>
@@ -9266,7 +9862,7 @@
 </file>
 
 <file path=ppt/slides/slide8.xml><?xml version="1.0" encoding="utf-8"?>
-<p:sld xmlns:a="http://schemas.openxmlformats.org/drawingml/2006/main" xmlns:p="http://schemas.openxmlformats.org/presentationml/2006/main" xmlns:r="http://schemas.openxmlformats.org/officeDocument/2006/relationships">
+<p:sld xmlns:a="http://schemas.openxmlformats.org/drawingml/2006/main" xmlns:r="http://schemas.openxmlformats.org/officeDocument/2006/relationships" xmlns:p="http://schemas.openxmlformats.org/presentationml/2006/main">
   <p:cSld>
     <p:spTree>
       <p:nvGrpSpPr>
@@ -9274,7 +9870,14 @@
         <p:cNvGrpSpPr/>
         <p:nvPr/>
       </p:nvGrpSpPr>
-      <p:grpSpPr/>
+      <p:grpSpPr>
+        <a:xfrm>
+          <a:off x="0" y="0"/>
+          <a:ext cx="0" cy="0"/>
+          <a:chOff x="0" y="0"/>
+          <a:chExt cx="0" cy="0"/>
+        </a:xfrm>
+      </p:grpSpPr>
       <p:sp>
         <p:nvSpPr>
           <p:cNvPr id="2" name="Rectangle 1"/>
@@ -9315,6 +9918,7 @@
           <a:lstStyle/>
           <a:p>
             <a:pPr algn="ctr"/>
+            <a:endParaRPr/>
           </a:p>
         </p:txBody>
       </p:sp>
@@ -9354,7 +9958,7 @@
           </a:fontRef>
         </p:style>
         <p:txBody>
-          <a:bodyPr rtlCol="0" anchor="ctr" wrap="none" tIns="0" bIns="0" lIns="381600" rIns="381600"/>
+          <a:bodyPr wrap="none" lIns="381600" tIns="0" rIns="381600" bIns="0" rtlCol="0" anchor="ctr"/>
           <a:lstStyle/>
           <a:p>
             <a:pPr algn="l"/>
@@ -9410,6 +10014,7 @@
           <a:lstStyle/>
           <a:p>
             <a:pPr algn="ctr"/>
+            <a:endParaRPr/>
           </a:p>
         </p:txBody>
       </p:sp>
@@ -9430,7 +10035,7 @@
           <a:noFill/>
         </p:spPr>
         <p:txBody>
-          <a:bodyPr wrap="square" tIns="0" bIns="0" lIns="0" rIns="0">
+          <a:bodyPr wrap="square" lIns="0" tIns="0" rIns="0" bIns="0">
             <a:spAutoFit/>
           </a:bodyPr>
           <a:lstStyle/>
@@ -9493,6 +10098,7 @@
           <a:lstStyle/>
           <a:p>
             <a:pPr algn="ctr"/>
+            <a:endParaRPr/>
           </a:p>
         </p:txBody>
       </p:sp>
@@ -9513,7 +10119,7 @@
           <a:noFill/>
         </p:spPr>
         <p:txBody>
-          <a:bodyPr wrap="square" tIns="0" bIns="0" lIns="0" rIns="0">
+          <a:bodyPr wrap="square" lIns="0" tIns="0" rIns="0" bIns="0">
             <a:spAutoFit/>
           </a:bodyPr>
           <a:lstStyle/>
@@ -9540,7 +10146,7 @@
 </file>
 
 <file path=ppt/slides/slide9.xml><?xml version="1.0" encoding="utf-8"?>
-<p:sld xmlns:a="http://schemas.openxmlformats.org/drawingml/2006/main" xmlns:p="http://schemas.openxmlformats.org/presentationml/2006/main" xmlns:r="http://schemas.openxmlformats.org/officeDocument/2006/relationships">
+<p:sld xmlns:a="http://schemas.openxmlformats.org/drawingml/2006/main" xmlns:r="http://schemas.openxmlformats.org/officeDocument/2006/relationships" xmlns:p="http://schemas.openxmlformats.org/presentationml/2006/main">
   <p:cSld>
     <p:spTree>
       <p:nvGrpSpPr>
@@ -9548,7 +10154,14 @@
         <p:cNvGrpSpPr/>
         <p:nvPr/>
       </p:nvGrpSpPr>
-      <p:grpSpPr/>
+      <p:grpSpPr>
+        <a:xfrm>
+          <a:off x="0" y="0"/>
+          <a:ext cx="0" cy="0"/>
+          <a:chOff x="0" y="0"/>
+          <a:chExt cx="0" cy="0"/>
+        </a:xfrm>
+      </p:grpSpPr>
       <p:sp>
         <p:nvSpPr>
           <p:cNvPr id="2" name="Rectangle 1"/>
@@ -9589,6 +10202,7 @@
           <a:lstStyle/>
           <a:p>
             <a:pPr algn="ctr"/>
+            <a:endParaRPr/>
           </a:p>
         </p:txBody>
       </p:sp>
@@ -9628,7 +10242,7 @@
           </a:fontRef>
         </p:style>
         <p:txBody>
-          <a:bodyPr rtlCol="0" anchor="ctr" wrap="none" tIns="0" bIns="0" lIns="381600" rIns="381600"/>
+          <a:bodyPr wrap="none" lIns="381600" tIns="0" rIns="381600" bIns="0" rtlCol="0" anchor="ctr"/>
           <a:lstStyle/>
           <a:p>
             <a:pPr algn="l"/>
@@ -9684,6 +10298,7 @@
           <a:lstStyle/>
           <a:p>
             <a:pPr algn="ctr"/>
+            <a:endParaRPr/>
           </a:p>
         </p:txBody>
       </p:sp>
@@ -9704,7 +10319,7 @@
           <a:noFill/>
         </p:spPr>
         <p:txBody>
-          <a:bodyPr wrap="square" tIns="0" bIns="0" lIns="0" rIns="0">
+          <a:bodyPr wrap="square" lIns="0" tIns="0" rIns="0" bIns="0">
             <a:spAutoFit/>
           </a:bodyPr>
           <a:lstStyle/>
@@ -9767,6 +10382,7 @@
           <a:lstStyle/>
           <a:p>
             <a:pPr algn="ctr"/>
+            <a:endParaRPr/>
           </a:p>
         </p:txBody>
       </p:sp>
@@ -9787,7 +10403,7 @@
           <a:noFill/>
         </p:spPr>
         <p:txBody>
-          <a:bodyPr wrap="square" tIns="0" bIns="0" lIns="0" rIns="0">
+          <a:bodyPr wrap="square" lIns="0" tIns="0" rIns="0" bIns="0">
             <a:spAutoFit/>
           </a:bodyPr>
           <a:lstStyle/>

</xml_diff>